<commit_message>
updates to lecture notes + slides
</commit_message>
<xml_diff>
--- a/docs/lecture_slides/Week 2/Week2_Lecture3_Slides_1_19_2024.pptx
+++ b/docs/lecture_slides/Week 2/Week2_Lecture3_Slides_1_19_2024.pptx
@@ -14081,8 +14081,8 @@
         </p:nvSpPr>
         <p:spPr>
           <a:xfrm>
-            <a:off x="838200" y="1620000"/>
-            <a:ext cx="10515600" cy="1150000"/>
+            <a:off x="838200" y="1500000"/>
+            <a:ext cx="10515600" cy="980000"/>
           </a:xfrm>
           <a:prstGeom prst="roundRect">
             <a:avLst>
@@ -14108,7 +14108,7 @@
               <a:buNone/>
             </a:pPr>
             <a:r>
-              <a:rPr lang="en-US" sz="1800" b="1" dirty="0">
+              <a:rPr lang="en-US" sz="1700" b="1" dirty="0">
                 <a:solidFill>
                   <a:srgbClr val="4472C4"/>
                 </a:solidFill>
@@ -14116,8 +14116,8 @@
               <a:t>1   </a:t>
             </a:r>
             <a:r>
-              <a:rPr lang="en-US" sz="1800" b="1" dirty="0"/>
-              <a:t>What do we use data for?</a:t>
+              <a:rPr lang="en-US" sz="1700" b="1" dirty="0"/>
+              <a:t>What is a statistic?</a:t>
             </a:r>
           </a:p>
         </p:txBody>
@@ -14130,8 +14130,8 @@
         </p:nvSpPr>
         <p:spPr>
           <a:xfrm>
-            <a:off x="1066800" y="2240000"/>
-            <a:ext cx="10058400" cy="438560"/>
+            <a:off x="1066800" y="2060000"/>
+            <a:ext cx="10058400" cy="328560"/>
           </a:xfrm>
           <a:prstGeom prst="rect">
             <a:avLst/>
@@ -14148,12 +14148,12 @@
               <a:buNone/>
             </a:pPr>
             <a:r>
-              <a:rPr lang="en-US" sz="1600" dirty="0">
+              <a:rPr lang="en-US" sz="1500" dirty="0">
                 <a:solidFill>
                   <a:srgbClr val="C00000"/>
                 </a:solidFill>
               </a:rPr>
-              <a:t>To answer questions about a population.</a:t>
+              <a:t>A numerical characteristic of a sample – a number computed from the observations we actually collected.</a:t>
             </a:r>
           </a:p>
         </p:txBody>
@@ -14166,8 +14166,8 @@
         </p:nvSpPr>
         <p:spPr>
           <a:xfrm>
-            <a:off x="838200" y="2870000"/>
-            <a:ext cx="10515600" cy="1150000"/>
+            <a:off x="838200" y="2560000"/>
+            <a:ext cx="10515600" cy="980000"/>
           </a:xfrm>
           <a:prstGeom prst="roundRect">
             <a:avLst>
@@ -14193,7 +14193,7 @@
               <a:buNone/>
             </a:pPr>
             <a:r>
-              <a:rPr lang="en-US" sz="1800" b="1" dirty="0">
+              <a:rPr lang="en-US" sz="1700" b="1" dirty="0">
                 <a:solidFill>
                   <a:srgbClr val="4472C4"/>
                 </a:solidFill>
@@ -14201,8 +14201,8 @@
               <a:t>2   </a:t>
             </a:r>
             <a:r>
-              <a:rPr lang="en-US" sz="1800" b="1" dirty="0"/>
-              <a:t>What is a population?</a:t>
+              <a:rPr lang="en-US" sz="1700" b="1" dirty="0"/>
+              <a:t>What is a parameter?</a:t>
             </a:r>
           </a:p>
         </p:txBody>
@@ -14215,8 +14215,8 @@
         </p:nvSpPr>
         <p:spPr>
           <a:xfrm>
-            <a:off x="1066800" y="3490000"/>
-            <a:ext cx="10058400" cy="438560"/>
+            <a:off x="1066800" y="3120000"/>
+            <a:ext cx="10058400" cy="328560"/>
           </a:xfrm>
           <a:prstGeom prst="rect">
             <a:avLst/>
@@ -14233,12 +14233,12 @@
               <a:buNone/>
             </a:pPr>
             <a:r>
-              <a:rPr lang="en-US" sz="1600" dirty="0">
+              <a:rPr lang="en-US" sz="1500" dirty="0">
                 <a:solidFill>
                   <a:srgbClr val="C00000"/>
                 </a:solidFill>
               </a:rPr>
-              <a:t>The set of all observations of interest – observed and unobserved.</a:t>
+              <a:t>The same kind of number for a population, computed from every observation – and usually unknown.</a:t>
             </a:r>
           </a:p>
         </p:txBody>
@@ -14251,8 +14251,8 @@
         </p:nvSpPr>
         <p:spPr>
           <a:xfrm>
-            <a:off x="838200" y="4120000"/>
-            <a:ext cx="10515600" cy="1150000"/>
+            <a:off x="838200" y="3620000"/>
+            <a:ext cx="10515600" cy="980000"/>
           </a:xfrm>
           <a:prstGeom prst="roundRect">
             <a:avLst>
@@ -14278,7 +14278,7 @@
               <a:buNone/>
             </a:pPr>
             <a:r>
-              <a:rPr lang="en-US" sz="1800" b="1" dirty="0">
+              <a:rPr lang="en-US" sz="1700" b="1" dirty="0">
                 <a:solidFill>
                   <a:srgbClr val="4472C4"/>
                 </a:solidFill>
@@ -14286,8 +14286,8 @@
               <a:t>3   </a:t>
             </a:r>
             <a:r>
-              <a:rPr lang="en-US" sz="1800" b="1" dirty="0"/>
-              <a:t>What is a sample?</a:t>
+              <a:rPr lang="en-US" sz="1700" b="1" dirty="0"/>
+              <a:t>What do we use data for?</a:t>
             </a:r>
           </a:p>
         </p:txBody>
@@ -14300,8 +14300,8 @@
         </p:nvSpPr>
         <p:spPr>
           <a:xfrm>
-            <a:off x="1066800" y="4740000"/>
-            <a:ext cx="10058400" cy="438560"/>
+            <a:off x="1066800" y="4180000"/>
+            <a:ext cx="10058400" cy="328560"/>
           </a:xfrm>
           <a:prstGeom prst="rect">
             <a:avLst/>
@@ -14318,12 +14318,12 @@
               <a:buNone/>
             </a:pPr>
             <a:r>
-              <a:rPr lang="en-US" sz="1600" dirty="0">
+              <a:rPr lang="en-US" sz="1500" dirty="0">
                 <a:solidFill>
                   <a:srgbClr val="C00000"/>
                 </a:solidFill>
               </a:rPr>
-              <a:t>The subset of the population that we actually observe.</a:t>
+              <a:t>To answer questions about a population.</a:t>
             </a:r>
           </a:p>
         </p:txBody>
@@ -14336,8 +14336,8 @@
         </p:nvSpPr>
         <p:spPr>
           <a:xfrm>
-            <a:off x="838200" y="5370000"/>
-            <a:ext cx="10515600" cy="1150000"/>
+            <a:off x="838200" y="4680000"/>
+            <a:ext cx="10515600" cy="980000"/>
           </a:xfrm>
           <a:prstGeom prst="roundRect">
             <a:avLst>
@@ -14363,7 +14363,7 @@
               <a:buNone/>
             </a:pPr>
             <a:r>
-              <a:rPr lang="en-US" sz="1800" b="1" dirty="0">
+              <a:rPr lang="en-US" sz="1700" b="1" dirty="0">
                 <a:solidFill>
                   <a:srgbClr val="4472C4"/>
                 </a:solidFill>
@@ -14371,8 +14371,8 @@
               <a:t>4   </a:t>
             </a:r>
             <a:r>
-              <a:rPr lang="en-US" sz="1800" b="1" dirty="0"/>
-              <a:t>What do we call the way we collect the data?</a:t>
+              <a:rPr lang="en-US" sz="1700" b="1" dirty="0"/>
+              <a:t>What is a population?</a:t>
             </a:r>
           </a:p>
         </p:txBody>
@@ -14385,8 +14385,8 @@
         </p:nvSpPr>
         <p:spPr>
           <a:xfrm>
-            <a:off x="1066800" y="5990000"/>
-            <a:ext cx="10058400" cy="438560"/>
+            <a:off x="1066800" y="5240000"/>
+            <a:ext cx="10058400" cy="328560"/>
           </a:xfrm>
           <a:prstGeom prst="rect">
             <a:avLst/>
@@ -14403,12 +14403,97 @@
               <a:buNone/>
             </a:pPr>
             <a:r>
-              <a:rPr lang="en-US" sz="1600" dirty="0">
+              <a:rPr lang="en-US" sz="1500" dirty="0">
                 <a:solidFill>
                   <a:srgbClr val="C00000"/>
                 </a:solidFill>
               </a:rPr>
-              <a:t>The sampling design.</a:t>
+              <a:t>The set of all observations of interest – observed and unobserved.</a:t>
+            </a:r>
+          </a:p>
+        </p:txBody>
+      </p:sp>
+      <p:sp>
+        <p:nvSpPr>
+          <p:cNvPr id="11" name="Question 5"/>
+          <p:cNvSpPr/>
+          <p:nvPr/>
+        </p:nvSpPr>
+        <p:spPr>
+          <a:xfrm>
+            <a:off x="838200" y="5740000"/>
+            <a:ext cx="10515600" cy="980000"/>
+          </a:xfrm>
+          <a:prstGeom prst="roundRect">
+            <a:avLst>
+              <a:gd name="adj" fmla="val 4000"/>
+            </a:avLst>
+          </a:prstGeom>
+          <a:solidFill>
+            <a:srgbClr val="F2F6FC"/>
+          </a:solidFill>
+          <a:ln w="19050">
+            <a:solidFill>
+              <a:schemeClr val="accent1"/>
+            </a:solidFill>
+          </a:ln>
+        </p:spPr>
+        <p:txBody>
+          <a:bodyPr lIns="228600" tIns="182880" rIns="228600" bIns="91440" anchor="t">
+            <a:normAutofit/>
+          </a:bodyPr>
+          <a:lstStyle/>
+          <a:p>
+            <a:pPr marL="0" indent="0">
+              <a:buNone/>
+            </a:pPr>
+            <a:r>
+              <a:rPr lang="en-US" sz="1700" b="1" dirty="0">
+                <a:solidFill>
+                  <a:srgbClr val="4472C4"/>
+                </a:solidFill>
+              </a:rPr>
+              <a:t>5   </a:t>
+            </a:r>
+            <a:r>
+              <a:rPr lang="en-US" sz="1700" b="1" dirty="0"/>
+              <a:t>What is a sample?</a:t>
+            </a:r>
+          </a:p>
+        </p:txBody>
+      </p:sp>
+      <p:sp>
+        <p:nvSpPr>
+          <p:cNvPr id="12" name="Answer 5"/>
+          <p:cNvSpPr txBox="1"/>
+          <p:nvPr/>
+        </p:nvSpPr>
+        <p:spPr>
+          <a:xfrm>
+            <a:off x="1066800" y="6300000"/>
+            <a:ext cx="10058400" cy="328560"/>
+          </a:xfrm>
+          <a:prstGeom prst="rect">
+            <a:avLst/>
+          </a:prstGeom>
+          <a:noFill/>
+        </p:spPr>
+        <p:txBody>
+          <a:bodyPr wrap="square" lIns="0" tIns="0" rIns="0" bIns="0">
+            <a:normAutofit/>
+          </a:bodyPr>
+          <a:lstStyle/>
+          <a:p>
+            <a:pPr marL="0" indent="0">
+              <a:buNone/>
+            </a:pPr>
+            <a:r>
+              <a:rPr lang="en-US" sz="1500" dirty="0">
+                <a:solidFill>
+                  <a:srgbClr val="C00000"/>
+                </a:solidFill>
+              </a:rPr>
+              <a:t>The subset of the population that we actually observe.</a:t>
             </a:r>
           </a:p>
         </p:txBody>
@@ -14791,6 +14876,96 @@
                       </p:childTnLst>
                     </p:cTn>
                   </p:par>
+                  <p:par>
+                    <p:cTn id="35" fill="hold">
+                      <p:stCondLst>
+                        <p:cond delay="indefinite"/>
+                      </p:stCondLst>
+                      <p:childTnLst>
+                        <p:par>
+                          <p:cTn id="36" fill="hold">
+                            <p:stCondLst>
+                              <p:cond delay="0"/>
+                            </p:stCondLst>
+                            <p:childTnLst>
+                              <p:par>
+                                <p:cTn id="37" presetID="1" presetClass="entr" presetSubtype="0" fill="hold" nodeType="clickEffect">
+                                  <p:stCondLst>
+                                    <p:cond delay="0"/>
+                                  </p:stCondLst>
+                                  <p:childTnLst>
+                                    <p:set>
+                                      <p:cBhvr>
+                                        <p:cTn id="38" dur="1" fill="hold">
+                                          <p:stCondLst>
+                                            <p:cond delay="0"/>
+                                          </p:stCondLst>
+                                        </p:cTn>
+                                        <p:tgtEl>
+                                          <p:spTgt spid="11"/>
+                                        </p:tgtEl>
+                                        <p:attrNameLst>
+                                          <p:attrName>style.visibility</p:attrName>
+                                        </p:attrNameLst>
+                                      </p:cBhvr>
+                                      <p:to>
+                                        <p:strVal val="visible"/>
+                                      </p:to>
+                                    </p:set>
+                                  </p:childTnLst>
+                                </p:cTn>
+                              </p:par>
+                            </p:childTnLst>
+                          </p:cTn>
+                        </p:par>
+                      </p:childTnLst>
+                    </p:cTn>
+                  </p:par>
+                  <p:par>
+                    <p:cTn id="39" fill="hold">
+                      <p:stCondLst>
+                        <p:cond delay="indefinite"/>
+                      </p:stCondLst>
+                      <p:childTnLst>
+                        <p:par>
+                          <p:cTn id="40" fill="hold">
+                            <p:stCondLst>
+                              <p:cond delay="0"/>
+                            </p:stCondLst>
+                            <p:childTnLst>
+                              <p:par>
+                                <p:cTn id="41" presetID="1" presetClass="entr" presetSubtype="0" fill="hold" nodeType="clickEffect">
+                                  <p:stCondLst>
+                                    <p:cond delay="0"/>
+                                  </p:stCondLst>
+                                  <p:childTnLst>
+                                    <p:set>
+                                      <p:cBhvr>
+                                        <p:cTn id="42" dur="1" fill="hold">
+                                          <p:stCondLst>
+                                            <p:cond delay="0"/>
+                                          </p:stCondLst>
+                                        </p:cTn>
+                                        <p:tgtEl>
+                                          <p:spTgt spid="12"/>
+                                        </p:tgtEl>
+                                        <p:attrNameLst>
+                                          <p:attrName>style.visibility</p:attrName>
+                                        </p:attrNameLst>
+                                      </p:cBhvr>
+                                      <p:to>
+                                        <p:strVal val="visible"/>
+                                      </p:to>
+                                    </p:set>
+                                  </p:childTnLst>
+                                </p:cTn>
+                              </p:par>
+                            </p:childTnLst>
+                          </p:cTn>
+                        </p:par>
+                      </p:childTnLst>
+                    </p:cTn>
+                  </p:par>
                 </p:childTnLst>
               </p:cTn>
               <p:prevCondLst>
@@ -15594,6 +15769,232 @@
   <p:clrMapOvr>
     <a:masterClrMapping/>
   </p:clrMapOvr>
+  <p:timing>
+    <p:tnLst>
+      <p:par>
+        <p:cTn id="1" dur="indefinite" restart="never" nodeType="tmRoot">
+          <p:childTnLst>
+            <p:seq concurrent="1" nextAc="seek">
+              <p:cTn id="2" dur="indefinite" nodeType="mainSeq">
+                <p:childTnLst>
+                  <p:par>
+                    <p:cTn id="3" fill="hold">
+                      <p:stCondLst>
+                        <p:cond delay="indefinite"/>
+                      </p:stCondLst>
+                      <p:childTnLst>
+                        <p:par>
+                          <p:cTn id="4" fill="hold">
+                            <p:stCondLst>
+                              <p:cond delay="0"/>
+                            </p:stCondLst>
+                            <p:childTnLst>
+                              <p:par>
+                                <p:cTn id="5" presetID="1" presetClass="entr" presetSubtype="0" fill="hold" nodeType="clickEffect">
+                                  <p:stCondLst>
+                                    <p:cond delay="0"/>
+                                  </p:stCondLst>
+                                  <p:childTnLst>
+                                    <p:set>
+                                      <p:cBhvr>
+                                        <p:cTn id="6" dur="1" fill="hold">
+                                          <p:stCondLst>
+                                            <p:cond delay="0"/>
+                                          </p:stCondLst>
+                                        </p:cTn>
+                                        <p:tgtEl>
+                                          <p:spTgt spid="3">
+                                            <p:txEl>
+                                              <p:pRg st="2" end="4"/>
+                                            </p:txEl>
+                                          </p:spTgt>
+                                        </p:tgtEl>
+                                        <p:attrNameLst>
+                                          <p:attrName>style.visibility</p:attrName>
+                                        </p:attrNameLst>
+                                      </p:cBhvr>
+                                      <p:to>
+                                        <p:strVal val="visible"/>
+                                      </p:to>
+                                    </p:set>
+                                  </p:childTnLst>
+                                </p:cTn>
+                              </p:par>
+                            </p:childTnLst>
+                          </p:cTn>
+                        </p:par>
+                      </p:childTnLst>
+                    </p:cTn>
+                  </p:par>
+                  <p:par>
+                    <p:cTn id="7" fill="hold">
+                      <p:stCondLst>
+                        <p:cond delay="indefinite"/>
+                      </p:stCondLst>
+                      <p:childTnLst>
+                        <p:par>
+                          <p:cTn id="8" fill="hold">
+                            <p:stCondLst>
+                              <p:cond delay="0"/>
+                            </p:stCondLst>
+                            <p:childTnLst>
+                              <p:par>
+                                <p:cTn id="9" presetID="1" presetClass="entr" presetSubtype="0" fill="hold" nodeType="clickEffect">
+                                  <p:stCondLst>
+                                    <p:cond delay="0"/>
+                                  </p:stCondLst>
+                                  <p:childTnLst>
+                                    <p:set>
+                                      <p:cBhvr>
+                                        <p:cTn id="10" dur="1" fill="hold">
+                                          <p:stCondLst>
+                                            <p:cond delay="0"/>
+                                          </p:stCondLst>
+                                        </p:cTn>
+                                        <p:tgtEl>
+                                          <p:spTgt spid="3">
+                                            <p:txEl>
+                                              <p:pRg st="6" end="7"/>
+                                            </p:txEl>
+                                          </p:spTgt>
+                                        </p:tgtEl>
+                                        <p:attrNameLst>
+                                          <p:attrName>style.visibility</p:attrName>
+                                        </p:attrNameLst>
+                                      </p:cBhvr>
+                                      <p:to>
+                                        <p:strVal val="visible"/>
+                                      </p:to>
+                                    </p:set>
+                                  </p:childTnLst>
+                                </p:cTn>
+                              </p:par>
+                            </p:childTnLst>
+                          </p:cTn>
+                        </p:par>
+                      </p:childTnLst>
+                    </p:cTn>
+                  </p:par>
+                  <p:par>
+                    <p:cTn id="11" fill="hold">
+                      <p:stCondLst>
+                        <p:cond delay="indefinite"/>
+                      </p:stCondLst>
+                      <p:childTnLst>
+                        <p:par>
+                          <p:cTn id="12" fill="hold">
+                            <p:stCondLst>
+                              <p:cond delay="0"/>
+                            </p:stCondLst>
+                            <p:childTnLst>
+                              <p:par>
+                                <p:cTn id="13" presetID="1" presetClass="entr" presetSubtype="0" fill="hold" nodeType="clickEffect">
+                                  <p:stCondLst>
+                                    <p:cond delay="0"/>
+                                  </p:stCondLst>
+                                  <p:childTnLst>
+                                    <p:set>
+                                      <p:cBhvr>
+                                        <p:cTn id="14" dur="1" fill="hold">
+                                          <p:stCondLst>
+                                            <p:cond delay="0"/>
+                                          </p:stCondLst>
+                                        </p:cTn>
+                                        <p:tgtEl>
+                                          <p:spTgt spid="3">
+                                            <p:txEl>
+                                              <p:pRg st="9" end="9"/>
+                                            </p:txEl>
+                                          </p:spTgt>
+                                        </p:tgtEl>
+                                        <p:attrNameLst>
+                                          <p:attrName>style.visibility</p:attrName>
+                                        </p:attrNameLst>
+                                      </p:cBhvr>
+                                      <p:to>
+                                        <p:strVal val="visible"/>
+                                      </p:to>
+                                    </p:set>
+                                  </p:childTnLst>
+                                </p:cTn>
+                              </p:par>
+                            </p:childTnLst>
+                          </p:cTn>
+                        </p:par>
+                      </p:childTnLst>
+                    </p:cTn>
+                  </p:par>
+                  <p:par>
+                    <p:cTn id="15" fill="hold">
+                      <p:stCondLst>
+                        <p:cond delay="indefinite"/>
+                      </p:stCondLst>
+                      <p:childTnLst>
+                        <p:par>
+                          <p:cTn id="16" fill="hold">
+                            <p:stCondLst>
+                              <p:cond delay="0"/>
+                            </p:stCondLst>
+                            <p:childTnLst>
+                              <p:par>
+                                <p:cTn id="17" presetID="1" presetClass="entr" presetSubtype="0" fill="hold" nodeType="clickEffect">
+                                  <p:stCondLst>
+                                    <p:cond delay="0"/>
+                                  </p:stCondLst>
+                                  <p:childTnLst>
+                                    <p:set>
+                                      <p:cBhvr>
+                                        <p:cTn id="18" dur="1" fill="hold">
+                                          <p:stCondLst>
+                                            <p:cond delay="0"/>
+                                          </p:stCondLst>
+                                        </p:cTn>
+                                        <p:tgtEl>
+                                          <p:spTgt spid="3">
+                                            <p:txEl>
+                                              <p:pRg st="11" end="11"/>
+                                            </p:txEl>
+                                          </p:spTgt>
+                                        </p:tgtEl>
+                                        <p:attrNameLst>
+                                          <p:attrName>style.visibility</p:attrName>
+                                        </p:attrNameLst>
+                                      </p:cBhvr>
+                                      <p:to>
+                                        <p:strVal val="visible"/>
+                                      </p:to>
+                                    </p:set>
+                                  </p:childTnLst>
+                                </p:cTn>
+                              </p:par>
+                            </p:childTnLst>
+                          </p:cTn>
+                        </p:par>
+                      </p:childTnLst>
+                    </p:cTn>
+                  </p:par>
+                </p:childTnLst>
+              </p:cTn>
+              <p:prevCondLst>
+                <p:cond evt="onPrev" delay="0">
+                  <p:tgtEl>
+                    <p:sldTgt/>
+                  </p:tgtEl>
+                </p:cond>
+              </p:prevCondLst>
+              <p:nextCondLst>
+                <p:cond evt="onNext" delay="0">
+                  <p:tgtEl>
+                    <p:sldTgt/>
+                  </p:tgtEl>
+                </p:cond>
+              </p:nextCondLst>
+            </p:seq>
+          </p:childTnLst>
+        </p:cTn>
+      </p:par>
+    </p:tnLst>
+  </p:timing>
 </p:sld>
 </file>
 
@@ -15869,6 +16270,66 @@
       </p:sp>
       <p:pic>
         <p:nvPicPr>
+          <p:cNvPr id="30" name="Table stage 1">
+            <a:extLst>
+              <a:ext uri="{FF2B5EF4-FFF2-40B4-BE49-F238E27FC236}">
+                <a16:creationId xmlns:a16="http://schemas.microsoft.com/office/drawing/2014/main" id="{A726F141-28A4-5B62-1A80-B214989D15D2}"/>
+              </a:ext>
+            </a:extLst>
+          </p:cNvPr>
+          <p:cNvPicPr>
+            <a:picLocks noChangeAspect="1"/>
+          </p:cNvPicPr>
+          <p:nvPr/>
+        </p:nvPicPr>
+        <p:blipFill>
+          <a:blip r:embed="rId5"/>
+          <a:stretch>
+            <a:fillRect/>
+          </a:stretch>
+        </p:blipFill>
+        <p:spPr>
+          <a:xfrm>
+            <a:off x="5661891" y="1887427"/>
+            <a:ext cx="6358151" cy="2636307"/>
+          </a:xfrm>
+          <a:prstGeom prst="rect">
+            <a:avLst/>
+          </a:prstGeom>
+        </p:spPr>
+      </p:pic>
+      <p:pic>
+        <p:nvPicPr>
+          <p:cNvPr id="31" name="Table stage 2">
+            <a:extLst>
+              <a:ext uri="{FF2B5EF4-FFF2-40B4-BE49-F238E27FC236}">
+                <a16:creationId xmlns:a16="http://schemas.microsoft.com/office/drawing/2014/main" id="{A726F141-28A4-5B62-1A80-B214989D15D2}"/>
+              </a:ext>
+            </a:extLst>
+          </p:cNvPr>
+          <p:cNvPicPr>
+            <a:picLocks noChangeAspect="1"/>
+          </p:cNvPicPr>
+          <p:nvPr/>
+        </p:nvPicPr>
+        <p:blipFill>
+          <a:blip r:embed="rId6"/>
+          <a:stretch>
+            <a:fillRect/>
+          </a:stretch>
+        </p:blipFill>
+        <p:spPr>
+          <a:xfrm>
+            <a:off x="5661891" y="1887427"/>
+            <a:ext cx="6358151" cy="2636307"/>
+          </a:xfrm>
+          <a:prstGeom prst="rect">
+            <a:avLst/>
+          </a:prstGeom>
+        </p:spPr>
+      </p:pic>
+      <p:pic>
+        <p:nvPicPr>
           <p:cNvPr id="9" name="Picture 8">
             <a:extLst>
               <a:ext uri="{FF2B5EF4-FFF2-40B4-BE49-F238E27FC236}">
@@ -15907,6 +16368,188 @@
   <p:clrMapOvr>
     <a:masterClrMapping/>
   </p:clrMapOvr>
+  <p:timing>
+    <p:tnLst>
+      <p:par>
+        <p:cTn id="1" dur="indefinite" restart="never" nodeType="tmRoot">
+          <p:childTnLst>
+            <p:seq concurrent="1" nextAc="seek">
+              <p:cTn id="2" dur="indefinite" nodeType="mainSeq">
+                <p:childTnLst>
+                  <p:par>
+                    <p:cTn id="3" fill="hold">
+                      <p:stCondLst>
+                        <p:cond delay="indefinite"/>
+                      </p:stCondLst>
+                      <p:childTnLst>
+                        <p:par>
+                          <p:cTn id="4" fill="hold">
+                            <p:stCondLst>
+                              <p:cond delay="0"/>
+                            </p:stCondLst>
+                            <p:childTnLst>
+                              <p:par>
+                                <p:cTn id="5" presetID="1" presetClass="entr" presetSubtype="0" fill="hold" nodeType="clickEffect">
+                                  <p:stCondLst>
+                                    <p:cond delay="0"/>
+                                  </p:stCondLst>
+                                  <p:childTnLst>
+                                    <p:set>
+                                      <p:cBhvr>
+                                        <p:cTn id="6" dur="1" fill="hold">
+                                          <p:stCondLst>
+                                            <p:cond delay="0"/>
+                                          </p:stCondLst>
+                                        </p:cTn>
+                                        <p:tgtEl>
+                                          <p:spTgt spid="3">
+                                            <p:txEl>
+                                              <p:pRg st="4" end="5"/>
+                                            </p:txEl>
+                                          </p:spTgt>
+                                        </p:tgtEl>
+                                        <p:attrNameLst>
+                                          <p:attrName>style.visibility</p:attrName>
+                                        </p:attrNameLst>
+                                      </p:cBhvr>
+                                      <p:to>
+                                        <p:strVal val="visible"/>
+                                      </p:to>
+                                    </p:set>
+                                  </p:childTnLst>
+                                </p:cTn>
+                              </p:par>
+                              <p:par>
+                                <p:cTn id="7" presetID="1" presetClass="entr" presetSubtype="0" fill="hold" nodeType="withEffect">
+                                  <p:stCondLst>
+                                    <p:cond delay="0"/>
+                                  </p:stCondLst>
+                                  <p:childTnLst>
+                                    <p:set>
+                                      <p:cBhvr>
+                                        <p:cTn id="8" dur="1" fill="hold">
+                                          <p:stCondLst>
+                                            <p:cond delay="0"/>
+                                          </p:stCondLst>
+                                        </p:cTn>
+                                        <p:tgtEl>
+                                          <p:spTgt spid="31"/>
+                                        </p:tgtEl>
+                                        <p:attrNameLst>
+                                          <p:attrName>style.visibility</p:attrName>
+                                        </p:attrNameLst>
+                                      </p:cBhvr>
+                                      <p:to>
+                                        <p:strVal val="visible"/>
+                                      </p:to>
+                                    </p:set>
+                                  </p:childTnLst>
+                                </p:cTn>
+                              </p:par>
+                            </p:childTnLst>
+                          </p:cTn>
+                        </p:par>
+                      </p:childTnLst>
+                    </p:cTn>
+                  </p:par>
+                  <p:par>
+                    <p:cTn id="9" fill="hold">
+                      <p:stCondLst>
+                        <p:cond delay="indefinite"/>
+                      </p:stCondLst>
+                      <p:childTnLst>
+                        <p:par>
+                          <p:cTn id="10" fill="hold">
+                            <p:stCondLst>
+                              <p:cond delay="0"/>
+                            </p:stCondLst>
+                            <p:childTnLst>
+                              <p:par>
+                                <p:cTn id="11" presetID="1" presetClass="entr" presetSubtype="0" fill="hold" nodeType="clickEffect">
+                                  <p:stCondLst>
+                                    <p:cond delay="0"/>
+                                  </p:stCondLst>
+                                  <p:childTnLst>
+                                    <p:set>
+                                      <p:cBhvr>
+                                        <p:cTn id="12" dur="1" fill="hold">
+                                          <p:stCondLst>
+                                            <p:cond delay="0"/>
+                                          </p:stCondLst>
+                                        </p:cTn>
+                                        <p:tgtEl>
+                                          <p:spTgt spid="3">
+                                            <p:txEl>
+                                              <p:pRg st="6" end="6"/>
+                                            </p:txEl>
+                                          </p:spTgt>
+                                        </p:tgtEl>
+                                        <p:attrNameLst>
+                                          <p:attrName>style.visibility</p:attrName>
+                                        </p:attrNameLst>
+                                      </p:cBhvr>
+                                      <p:to>
+                                        <p:strVal val="visible"/>
+                                      </p:to>
+                                    </p:set>
+                                  </p:childTnLst>
+                                </p:cTn>
+                              </p:par>
+                              <p:par>
+                                <p:cTn id="13" presetID="1" presetClass="entr" presetSubtype="0" fill="hold" nodeType="withEffect">
+                                  <p:stCondLst>
+                                    <p:cond delay="0"/>
+                                  </p:stCondLst>
+                                  <p:childTnLst>
+                                    <p:set>
+                                      <p:cBhvr>
+                                        <p:cTn id="14" dur="1" fill="hold">
+                                          <p:stCondLst>
+                                            <p:cond delay="0"/>
+                                          </p:stCondLst>
+                                        </p:cTn>
+                                        <p:tgtEl>
+                                          <p:spTgt spid="9"/>
+                                        </p:tgtEl>
+                                        <p:attrNameLst>
+                                          <p:attrName>style.visibility</p:attrName>
+                                        </p:attrNameLst>
+                                      </p:cBhvr>
+                                      <p:to>
+                                        <p:strVal val="visible"/>
+                                      </p:to>
+                                    </p:set>
+                                  </p:childTnLst>
+                                </p:cTn>
+                              </p:par>
+                            </p:childTnLst>
+                          </p:cTn>
+                        </p:par>
+                      </p:childTnLst>
+                    </p:cTn>
+                  </p:par>
+                </p:childTnLst>
+              </p:cTn>
+              <p:prevCondLst>
+                <p:cond evt="onPrev" delay="0">
+                  <p:tgtEl>
+                    <p:sldTgt/>
+                  </p:tgtEl>
+                </p:cond>
+              </p:prevCondLst>
+              <p:nextCondLst>
+                <p:cond evt="onNext" delay="0">
+                  <p:tgtEl>
+                    <p:sldTgt/>
+                  </p:tgtEl>
+                </p:cond>
+              </p:nextCondLst>
+            </p:seq>
+          </p:childTnLst>
+        </p:cTn>
+      </p:par>
+    </p:tnLst>
+  </p:timing>
 </p:sld>
 </file>
 
@@ -16645,7 +17288,7 @@
           <a:noFill/>
         </p:spPr>
         <p:txBody>
-          <a:bodyPr wrap="square">
+          <a:bodyPr wrap="square" lIns="0" tIns="0" rIns="0" bIns="0">
             <a:normAutofit/>
           </a:bodyPr>
           <a:lstStyle/>
@@ -16655,7 +17298,7 @@
             </a:pPr>
             <a:r>
               <a:rPr lang="en-US" sz="1600" dirty="0"/>
-              <a:t>Twenty students report how many siblings they have:</a:t>
+              <a:t>Ten students report how many siblings they have. Writing the responses as a set:</a:t>
             </a:r>
           </a:p>
           <a:p>
@@ -16669,7 +17312,7 @@
               <a:rPr lang="en-US" sz="1500" dirty="0">
                 <a:latin typeface="Consolas" panose="020B0609020204030204"/>
               </a:rPr>
-              <a:t>0  1  1  2  0  3  1  2  1  0</a:t>
+              <a:t>R = {0, 1, 1, 2, 0,</a:t>
             </a:r>
           </a:p>
           <a:p>
@@ -16680,7 +17323,7 @@
               <a:rPr lang="en-US" sz="1500" dirty="0">
                 <a:latin typeface="Consolas" panose="020B0609020204030204"/>
               </a:rPr>
-              <a:t>4  2  1  1  3  0  2  1  5  1</a:t>
+              <a:t>        3, 1, 2, 1, 4}</a:t>
             </a:r>
           </a:p>
           <a:p>
@@ -16707,7 +17350,7 @@
         </p:nvGraphicFramePr>
         <p:xfrm>
           <a:off x="6400800" y="1750000"/>
-          <a:ext cx="4300000" cy="2960000"/>
+          <a:ext cx="4300000" cy="2380000"/>
         </p:xfrm>
         <a:graphic>
           <a:graphicData uri="http://schemas.openxmlformats.org/drawingml/2006/table">
@@ -16720,7 +17363,7 @@
                 <a:gridCol w="1000000"/>
                 <a:gridCol w="1400000"/>
               </a:tblGrid>
-              <a:tr h="370000">
+              <a:tr h="340000">
                 <a:tc>
                   <a:txBody>
                     <a:bodyPr/>
@@ -16729,7 +17372,7 @@
                       <a:pPr algn="l"/>
                       <a:r>
                         <a:rPr lang="en-US" sz="1400" dirty="0"/>
-                        <a:t>Siblings</a:t>
+                        <a:t>R</a:t>
                       </a:r>
                     </a:p>
                   </a:txBody>
@@ -16764,7 +17407,7 @@
                   <a:tcPr marL="68580" marR="68580" marT="0" marB="0" anchor="ctr"/>
                 </a:tc>
               </a:tr>
-              <a:tr h="370000">
+              <a:tr h="340000">
                 <a:tc>
                   <a:txBody>
                     <a:bodyPr/>
@@ -16774,6 +17417,50 @@
                       <a:r>
                         <a:rPr lang="en-US" sz="1400" dirty="0"/>
                         <a:t>0</a:t>
+                      </a:r>
+                    </a:p>
+                  </a:txBody>
+                  <a:tcPr marL="68580" marR="68580" marT="0" marB="0" anchor="ctr"/>
+                </a:tc>
+                <a:tc>
+                  <a:txBody>
+                    <a:bodyPr/>
+                    <a:lstStyle/>
+                    <a:p>
+                      <a:pPr algn="ctr"/>
+                      <a:r>
+                        <a:rPr lang="en-US" sz="1400" dirty="0"/>
+                        <a:t>2</a:t>
+                      </a:r>
+                    </a:p>
+                  </a:txBody>
+                  <a:tcPr marL="68580" marR="68580" marT="0" marB="0" anchor="ctr"/>
+                </a:tc>
+                <a:tc>
+                  <a:txBody>
+                    <a:bodyPr/>
+                    <a:lstStyle/>
+                    <a:p>
+                      <a:pPr algn="ctr"/>
+                      <a:r>
+                        <a:rPr lang="en-US" sz="1400" dirty="0"/>
+                        <a:t>0.20</a:t>
+                      </a:r>
+                    </a:p>
+                  </a:txBody>
+                  <a:tcPr marL="68580" marR="68580" marT="0" marB="0" anchor="ctr"/>
+                </a:tc>
+              </a:tr>
+              <a:tr h="340000">
+                <a:tc>
+                  <a:txBody>
+                    <a:bodyPr/>
+                    <a:lstStyle/>
+                    <a:p>
+                      <a:pPr algn="l"/>
+                      <a:r>
+                        <a:rPr lang="en-US" sz="1400" dirty="0"/>
+                        <a:t>1</a:t>
                       </a:r>
                     </a:p>
                   </a:txBody>
@@ -16801,50 +17488,6 @@
                       <a:pPr algn="ctr"/>
                       <a:r>
                         <a:rPr lang="en-US" sz="1400" dirty="0"/>
-                        <a:t>0.20</a:t>
-                      </a:r>
-                    </a:p>
-                  </a:txBody>
-                  <a:tcPr marL="68580" marR="68580" marT="0" marB="0" anchor="ctr"/>
-                </a:tc>
-              </a:tr>
-              <a:tr h="370000">
-                <a:tc>
-                  <a:txBody>
-                    <a:bodyPr/>
-                    <a:lstStyle/>
-                    <a:p>
-                      <a:pPr algn="l"/>
-                      <a:r>
-                        <a:rPr lang="en-US" sz="1400" dirty="0"/>
-                        <a:t>1</a:t>
-                      </a:r>
-                    </a:p>
-                  </a:txBody>
-                  <a:tcPr marL="68580" marR="68580" marT="0" marB="0" anchor="ctr"/>
-                </a:tc>
-                <a:tc>
-                  <a:txBody>
-                    <a:bodyPr/>
-                    <a:lstStyle/>
-                    <a:p>
-                      <a:pPr algn="ctr"/>
-                      <a:r>
-                        <a:rPr lang="en-US" sz="1400" dirty="0"/>
-                        <a:t>8</a:t>
-                      </a:r>
-                    </a:p>
-                  </a:txBody>
-                  <a:tcPr marL="68580" marR="68580" marT="0" marB="0" anchor="ctr"/>
-                </a:tc>
-                <a:tc>
-                  <a:txBody>
-                    <a:bodyPr/>
-                    <a:lstStyle/>
-                    <a:p>
-                      <a:pPr algn="ctr"/>
-                      <a:r>
-                        <a:rPr lang="en-US" sz="1400" dirty="0"/>
                         <a:t>0.40</a:t>
                       </a:r>
                     </a:p>
@@ -16852,7 +17495,7 @@
                   <a:tcPr marL="68580" marR="68580" marT="0" marB="0" anchor="ctr"/>
                 </a:tc>
               </a:tr>
-              <a:tr h="370000">
+              <a:tr h="340000">
                 <a:tc>
                   <a:txBody>
                     <a:bodyPr/>
@@ -16862,50 +17505,6 @@
                       <a:r>
                         <a:rPr lang="en-US" sz="1400" dirty="0"/>
                         <a:t>2</a:t>
-                      </a:r>
-                    </a:p>
-                  </a:txBody>
-                  <a:tcPr marL="68580" marR="68580" marT="0" marB="0" anchor="ctr"/>
-                </a:tc>
-                <a:tc>
-                  <a:txBody>
-                    <a:bodyPr/>
-                    <a:lstStyle/>
-                    <a:p>
-                      <a:pPr algn="ctr"/>
-                      <a:r>
-                        <a:rPr lang="en-US" sz="1400" dirty="0"/>
-                        <a:t>4</a:t>
-                      </a:r>
-                    </a:p>
-                  </a:txBody>
-                  <a:tcPr marL="68580" marR="68580" marT="0" marB="0" anchor="ctr"/>
-                </a:tc>
-                <a:tc>
-                  <a:txBody>
-                    <a:bodyPr/>
-                    <a:lstStyle/>
-                    <a:p>
-                      <a:pPr algn="ctr"/>
-                      <a:r>
-                        <a:rPr lang="en-US" sz="1400" dirty="0"/>
-                        <a:t>0.20</a:t>
-                      </a:r>
-                    </a:p>
-                  </a:txBody>
-                  <a:tcPr marL="68580" marR="68580" marT="0" marB="0" anchor="ctr"/>
-                </a:tc>
-              </a:tr>
-              <a:tr h="370000">
-                <a:tc>
-                  <a:txBody>
-                    <a:bodyPr/>
-                    <a:lstStyle/>
-                    <a:p>
-                      <a:pPr algn="l"/>
-                      <a:r>
-                        <a:rPr lang="en-US" sz="1400" dirty="0"/>
-                        <a:t>3</a:t>
                       </a:r>
                     </a:p>
                   </a:txBody>
@@ -16933,6 +17532,50 @@
                       <a:pPr algn="ctr"/>
                       <a:r>
                         <a:rPr lang="en-US" sz="1400" dirty="0"/>
+                        <a:t>0.20</a:t>
+                      </a:r>
+                    </a:p>
+                  </a:txBody>
+                  <a:tcPr marL="68580" marR="68580" marT="0" marB="0" anchor="ctr"/>
+                </a:tc>
+              </a:tr>
+              <a:tr h="340000">
+                <a:tc>
+                  <a:txBody>
+                    <a:bodyPr/>
+                    <a:lstStyle/>
+                    <a:p>
+                      <a:pPr algn="l"/>
+                      <a:r>
+                        <a:rPr lang="en-US" sz="1400" dirty="0"/>
+                        <a:t>3</a:t>
+                      </a:r>
+                    </a:p>
+                  </a:txBody>
+                  <a:tcPr marL="68580" marR="68580" marT="0" marB="0" anchor="ctr"/>
+                </a:tc>
+                <a:tc>
+                  <a:txBody>
+                    <a:bodyPr/>
+                    <a:lstStyle/>
+                    <a:p>
+                      <a:pPr algn="ctr"/>
+                      <a:r>
+                        <a:rPr lang="en-US" sz="1400" dirty="0"/>
+                        <a:t>1</a:t>
+                      </a:r>
+                    </a:p>
+                  </a:txBody>
+                  <a:tcPr marL="68580" marR="68580" marT="0" marB="0" anchor="ctr"/>
+                </a:tc>
+                <a:tc>
+                  <a:txBody>
+                    <a:bodyPr/>
+                    <a:lstStyle/>
+                    <a:p>
+                      <a:pPr algn="ctr"/>
+                      <a:r>
+                        <a:rPr lang="en-US" sz="1400" dirty="0"/>
                         <a:t>0.10</a:t>
                       </a:r>
                     </a:p>
@@ -16940,7 +17583,7 @@
                   <a:tcPr marL="68580" marR="68580" marT="0" marB="0" anchor="ctr"/>
                 </a:tc>
               </a:tr>
-              <a:tr h="370000">
+              <a:tr h="340000">
                 <a:tc>
                   <a:txBody>
                     <a:bodyPr/>
@@ -16977,58 +17620,14 @@
                       <a:pPr algn="ctr"/>
                       <a:r>
                         <a:rPr lang="en-US" sz="1400" dirty="0"/>
-                        <a:t>0.05</a:t>
+                        <a:t>0.10</a:t>
                       </a:r>
                     </a:p>
                   </a:txBody>
                   <a:tcPr marL="68580" marR="68580" marT="0" marB="0" anchor="ctr"/>
                 </a:tc>
               </a:tr>
-              <a:tr h="370000">
-                <a:tc>
-                  <a:txBody>
-                    <a:bodyPr/>
-                    <a:lstStyle/>
-                    <a:p>
-                      <a:pPr algn="l"/>
-                      <a:r>
-                        <a:rPr lang="en-US" sz="1400" dirty="0"/>
-                        <a:t>5</a:t>
-                      </a:r>
-                    </a:p>
-                  </a:txBody>
-                  <a:tcPr marL="68580" marR="68580" marT="0" marB="0" anchor="ctr"/>
-                </a:tc>
-                <a:tc>
-                  <a:txBody>
-                    <a:bodyPr/>
-                    <a:lstStyle/>
-                    <a:p>
-                      <a:pPr algn="ctr"/>
-                      <a:r>
-                        <a:rPr lang="en-US" sz="1400" dirty="0"/>
-                        <a:t>1</a:t>
-                      </a:r>
-                    </a:p>
-                  </a:txBody>
-                  <a:tcPr marL="68580" marR="68580" marT="0" marB="0" anchor="ctr"/>
-                </a:tc>
-                <a:tc>
-                  <a:txBody>
-                    <a:bodyPr/>
-                    <a:lstStyle/>
-                    <a:p>
-                      <a:pPr algn="ctr"/>
-                      <a:r>
-                        <a:rPr lang="en-US" sz="1400" dirty="0"/>
-                        <a:t>0.05</a:t>
-                      </a:r>
-                    </a:p>
-                  </a:txBody>
-                  <a:tcPr marL="68580" marR="68580" marT="0" marB="0" anchor="ctr"/>
-                </a:tc>
-              </a:tr>
-              <a:tr h="370000">
+              <a:tr h="340000">
                 <a:tc>
                   <a:txBody>
                     <a:bodyPr/>
@@ -17051,7 +17650,7 @@
                       <a:pPr algn="ctr"/>
                       <a:r>
                         <a:rPr lang="en-US" sz="1400" dirty="0"/>
-                        <a:t>20</a:t>
+                        <a:t>10</a:t>
                       </a:r>
                     </a:p>
                   </a:txBody>
@@ -17084,8 +17683,8 @@
         </p:nvSpPr>
         <p:spPr>
           <a:xfrm>
-            <a:off x="6400800" y="4970000"/>
-            <a:ext cx="4300000" cy="1400000"/>
+            <a:off x="6400800" y="4390000"/>
+            <a:ext cx="4300000" cy="1300000"/>
           </a:xfrm>
           <a:prstGeom prst="rect">
             <a:avLst/>
@@ -17093,7 +17692,7 @@
           <a:noFill/>
         </p:spPr>
         <p:txBody>
-          <a:bodyPr wrap="square">
+          <a:bodyPr wrap="square" lIns="0" tIns="0" rIns="0" bIns="0">
             <a:normAutofit/>
           </a:bodyPr>
           <a:lstStyle/>
@@ -17107,7 +17706,7 @@
                   <a:srgbClr val="C00000"/>
                 </a:solidFill>
               </a:rPr>
-              <a:t>Mode = 1. Median = 1 but the mean is 1.55: the mean is pulled above the median by the long right tail, so the distribution is skewed right.</a:t>
+              <a:t>Mode = 1. Median = 1 but the mean is 1.5: the mean is pulled above the median by the long right tail, so the distribution is skewed right.</a:t>
             </a:r>
           </a:p>
         </p:txBody>
@@ -17115,7 +17714,7 @@
     </p:spTree>
     <p:extLst>
       <p:ext uri="{BB962C8B-B14F-4D97-AF65-F5344CB8AC3E}">
-        <p14:creationId xmlns:p14="http://schemas.microsoft.com/office/powerpoint/2010/main" val="1517484004"/>
+        <p14:creationId xmlns:p14="http://schemas.microsoft.com/office/powerpoint/2010/main" val="1517484022"/>
       </p:ext>
     </p:extLst>
   </p:cSld>
@@ -17303,7 +17902,7 @@
           <a:noFill/>
         </p:spPr>
         <p:txBody>
-          <a:bodyPr wrap="square">
+          <a:bodyPr wrap="square" lIns="0" tIns="0" rIns="0" bIns="0">
             <a:normAutofit/>
           </a:bodyPr>
           <a:lstStyle/>
@@ -17313,7 +17912,7 @@
             </a:pPr>
             <a:r>
               <a:rPr lang="en-US" sz="1600" dirty="0"/>
-              <a:t>Fifteen observations of a continuous variable X:</a:t>
+              <a:t>Fifteen observations of a continuous variable, written as a set:</a:t>
             </a:r>
           </a:p>
           <a:p>
@@ -17327,7 +17926,7 @@
               <a:rPr lang="en-US" sz="1500" dirty="0">
                 <a:latin typeface="Consolas" panose="020B0609020204030204"/>
               </a:rPr>
-              <a:t>1.23  1.38  1.76  2.60  2.65</a:t>
+              <a:t>X = {1.23, 1.38, 1.76, 2.60, 2.65,</a:t>
             </a:r>
           </a:p>
           <a:p>
@@ -17338,7 +17937,7 @@
               <a:rPr lang="en-US" sz="1500" dirty="0">
                 <a:latin typeface="Consolas" panose="020B0609020204030204"/>
               </a:rPr>
-              <a:t>2.79  2.89  3.12  3.15  3.18</a:t>
+              <a:t>        2.79, 2.89, 3.12, 3.15, 3.18,</a:t>
             </a:r>
           </a:p>
           <a:p>
@@ -17349,7 +17948,7 @@
               <a:rPr lang="en-US" sz="1500" dirty="0">
                 <a:latin typeface="Consolas" panose="020B0609020204030204"/>
               </a:rPr>
-              <a:t>3.65  3.77  3.87  4.12  4.41</a:t>
+              <a:t>        3.65, 3.77, 3.87, 4.12, 4.41}</a:t>
             </a:r>
           </a:p>
           <a:p>
@@ -17361,7 +17960,7 @@
             </a:pPr>
             <a:r>
               <a:rPr lang="en-US" sz="1600" b="1" dirty="0"/>
-              <a:t>No two values are alike, so listing them gives 15 values of frequency 1 and tells us nothing. Group them into bins of width 0.5 starting at 1.0.</a:t>
+              <a:t>No two values are alike, so listing them gives 15 values of frequency 1 and tells us nothing. Group them into whole-number bins.</a:t>
             </a:r>
           </a:p>
         </p:txBody>
@@ -17375,8 +17974,8 @@
           <p:nvPr/>
         </p:nvGraphicFramePr>
         <p:xfrm>
-          <a:off x="6400800" y="1700000"/>
-          <a:ext cx="4300000" cy="3060000"/>
+          <a:off x="6400800" y="1620000"/>
+          <a:ext cx="4100000" cy="1920000"/>
         </p:xfrm>
         <a:graphic>
           <a:graphicData uri="http://schemas.openxmlformats.org/drawingml/2006/table">
@@ -17386,10 +17985,10 @@
               </a:tblPr>
               <a:tblGrid>
                 <a:gridCol w="1900000"/>
-                <a:gridCol w="1000000"/>
-                <a:gridCol w="1400000"/>
+                <a:gridCol w="900000"/>
+                <a:gridCol w="1300000"/>
               </a:tblGrid>
-              <a:tr h="340000">
+              <a:tr h="320000">
                 <a:tc>
                   <a:txBody>
                     <a:bodyPr/>
@@ -17433,7 +18032,7 @@
                   <a:tcPr marL="68580" marR="68580" marT="0" marB="0" anchor="ctr"/>
                 </a:tc>
               </a:tr>
-              <a:tr h="340000">
+              <a:tr h="320000">
                 <a:tc>
                   <a:txBody>
                     <a:bodyPr/>
@@ -17442,7 +18041,139 @@
                       <a:pPr algn="l"/>
                       <a:r>
                         <a:rPr lang="en-US" sz="1400" dirty="0"/>
-                        <a:t>1.0 &lt; X ≤ 1.5</a:t>
+                        <a:t>1 ≤ X &lt; 2</a:t>
+                      </a:r>
+                    </a:p>
+                  </a:txBody>
+                  <a:tcPr marL="68580" marR="68580" marT="0" marB="0" anchor="ctr"/>
+                </a:tc>
+                <a:tc>
+                  <a:txBody>
+                    <a:bodyPr/>
+                    <a:lstStyle/>
+                    <a:p>
+                      <a:pPr algn="ctr"/>
+                      <a:r>
+                        <a:rPr lang="en-US" sz="1400" dirty="0"/>
+                        <a:t>3</a:t>
+                      </a:r>
+                    </a:p>
+                  </a:txBody>
+                  <a:tcPr marL="68580" marR="68580" marT="0" marB="0" anchor="ctr"/>
+                </a:tc>
+                <a:tc>
+                  <a:txBody>
+                    <a:bodyPr/>
+                    <a:lstStyle/>
+                    <a:p>
+                      <a:pPr algn="ctr"/>
+                      <a:r>
+                        <a:rPr lang="en-US" sz="1400" dirty="0"/>
+                        <a:t>0.20</a:t>
+                      </a:r>
+                    </a:p>
+                  </a:txBody>
+                  <a:tcPr marL="68580" marR="68580" marT="0" marB="0" anchor="ctr"/>
+                </a:tc>
+              </a:tr>
+              <a:tr h="320000">
+                <a:tc>
+                  <a:txBody>
+                    <a:bodyPr/>
+                    <a:lstStyle/>
+                    <a:p>
+                      <a:pPr algn="l"/>
+                      <a:r>
+                        <a:rPr lang="en-US" sz="1400" dirty="0"/>
+                        <a:t>2 ≤ X &lt; 3</a:t>
+                      </a:r>
+                    </a:p>
+                  </a:txBody>
+                  <a:tcPr marL="68580" marR="68580" marT="0" marB="0" anchor="ctr"/>
+                </a:tc>
+                <a:tc>
+                  <a:txBody>
+                    <a:bodyPr/>
+                    <a:lstStyle/>
+                    <a:p>
+                      <a:pPr algn="ctr"/>
+                      <a:r>
+                        <a:rPr lang="en-US" sz="1400" dirty="0"/>
+                        <a:t>4</a:t>
+                      </a:r>
+                    </a:p>
+                  </a:txBody>
+                  <a:tcPr marL="68580" marR="68580" marT="0" marB="0" anchor="ctr"/>
+                </a:tc>
+                <a:tc>
+                  <a:txBody>
+                    <a:bodyPr/>
+                    <a:lstStyle/>
+                    <a:p>
+                      <a:pPr algn="ctr"/>
+                      <a:r>
+                        <a:rPr lang="en-US" sz="1400" dirty="0"/>
+                        <a:t>0.27</a:t>
+                      </a:r>
+                    </a:p>
+                  </a:txBody>
+                  <a:tcPr marL="68580" marR="68580" marT="0" marB="0" anchor="ctr"/>
+                </a:tc>
+              </a:tr>
+              <a:tr h="320000">
+                <a:tc>
+                  <a:txBody>
+                    <a:bodyPr/>
+                    <a:lstStyle/>
+                    <a:p>
+                      <a:pPr algn="l"/>
+                      <a:r>
+                        <a:rPr lang="en-US" sz="1400" dirty="0"/>
+                        <a:t>3 ≤ X &lt; 4</a:t>
+                      </a:r>
+                    </a:p>
+                  </a:txBody>
+                  <a:tcPr marL="68580" marR="68580" marT="0" marB="0" anchor="ctr"/>
+                </a:tc>
+                <a:tc>
+                  <a:txBody>
+                    <a:bodyPr/>
+                    <a:lstStyle/>
+                    <a:p>
+                      <a:pPr algn="ctr"/>
+                      <a:r>
+                        <a:rPr lang="en-US" sz="1400" dirty="0"/>
+                        <a:t>6</a:t>
+                      </a:r>
+                    </a:p>
+                  </a:txBody>
+                  <a:tcPr marL="68580" marR="68580" marT="0" marB="0" anchor="ctr"/>
+                </a:tc>
+                <a:tc>
+                  <a:txBody>
+                    <a:bodyPr/>
+                    <a:lstStyle/>
+                    <a:p>
+                      <a:pPr algn="ctr"/>
+                      <a:r>
+                        <a:rPr lang="en-US" sz="1400" dirty="0"/>
+                        <a:t>0.40</a:t>
+                      </a:r>
+                    </a:p>
+                  </a:txBody>
+                  <a:tcPr marL="68580" marR="68580" marT="0" marB="0" anchor="ctr"/>
+                </a:tc>
+              </a:tr>
+              <a:tr h="320000">
+                <a:tc>
+                  <a:txBody>
+                    <a:bodyPr/>
+                    <a:lstStyle/>
+                    <a:p>
+                      <a:pPr algn="l"/>
+                      <a:r>
+                        <a:rPr lang="en-US" sz="1400" dirty="0"/>
+                        <a:t>4 ≤ X &lt; 5</a:t>
                       </a:r>
                     </a:p>
                   </a:txBody>
@@ -17477,271 +18208,7 @@
                   <a:tcPr marL="68580" marR="68580" marT="0" marB="0" anchor="ctr"/>
                 </a:tc>
               </a:tr>
-              <a:tr h="340000">
-                <a:tc>
-                  <a:txBody>
-                    <a:bodyPr/>
-                    <a:lstStyle/>
-                    <a:p>
-                      <a:pPr algn="l"/>
-                      <a:r>
-                        <a:rPr lang="en-US" sz="1400" dirty="0"/>
-                        <a:t>1.5 &lt; X ≤ 2.0</a:t>
-                      </a:r>
-                    </a:p>
-                  </a:txBody>
-                  <a:tcPr marL="68580" marR="68580" marT="0" marB="0" anchor="ctr"/>
-                </a:tc>
-                <a:tc>
-                  <a:txBody>
-                    <a:bodyPr/>
-                    <a:lstStyle/>
-                    <a:p>
-                      <a:pPr algn="ctr"/>
-                      <a:r>
-                        <a:rPr lang="en-US" sz="1400" dirty="0"/>
-                        <a:t>1</a:t>
-                      </a:r>
-                    </a:p>
-                  </a:txBody>
-                  <a:tcPr marL="68580" marR="68580" marT="0" marB="0" anchor="ctr"/>
-                </a:tc>
-                <a:tc>
-                  <a:txBody>
-                    <a:bodyPr/>
-                    <a:lstStyle/>
-                    <a:p>
-                      <a:pPr algn="ctr"/>
-                      <a:r>
-                        <a:rPr lang="en-US" sz="1400" dirty="0"/>
-                        <a:t>0.07</a:t>
-                      </a:r>
-                    </a:p>
-                  </a:txBody>
-                  <a:tcPr marL="68580" marR="68580" marT="0" marB="0" anchor="ctr"/>
-                </a:tc>
-              </a:tr>
-              <a:tr h="340000">
-                <a:tc>
-                  <a:txBody>
-                    <a:bodyPr/>
-                    <a:lstStyle/>
-                    <a:p>
-                      <a:pPr algn="l"/>
-                      <a:r>
-                        <a:rPr lang="en-US" sz="1400" dirty="0"/>
-                        <a:t>2.0 &lt; X ≤ 2.5</a:t>
-                      </a:r>
-                    </a:p>
-                  </a:txBody>
-                  <a:tcPr marL="68580" marR="68580" marT="0" marB="0" anchor="ctr"/>
-                </a:tc>
-                <a:tc>
-                  <a:txBody>
-                    <a:bodyPr/>
-                    <a:lstStyle/>
-                    <a:p>
-                      <a:pPr algn="ctr"/>
-                      <a:r>
-                        <a:rPr lang="en-US" sz="1400" dirty="0"/>
-                        <a:t>0</a:t>
-                      </a:r>
-                    </a:p>
-                  </a:txBody>
-                  <a:tcPr marL="68580" marR="68580" marT="0" marB="0" anchor="ctr"/>
-                </a:tc>
-                <a:tc>
-                  <a:txBody>
-                    <a:bodyPr/>
-                    <a:lstStyle/>
-                    <a:p>
-                      <a:pPr algn="ctr"/>
-                      <a:r>
-                        <a:rPr lang="en-US" sz="1400" dirty="0"/>
-                        <a:t>0.00</a:t>
-                      </a:r>
-                    </a:p>
-                  </a:txBody>
-                  <a:tcPr marL="68580" marR="68580" marT="0" marB="0" anchor="ctr"/>
-                </a:tc>
-              </a:tr>
-              <a:tr h="340000">
-                <a:tc>
-                  <a:txBody>
-                    <a:bodyPr/>
-                    <a:lstStyle/>
-                    <a:p>
-                      <a:pPr algn="l"/>
-                      <a:r>
-                        <a:rPr lang="en-US" sz="1400" dirty="0"/>
-                        <a:t>2.5 &lt; X ≤ 3.0</a:t>
-                      </a:r>
-                    </a:p>
-                  </a:txBody>
-                  <a:tcPr marL="68580" marR="68580" marT="0" marB="0" anchor="ctr"/>
-                </a:tc>
-                <a:tc>
-                  <a:txBody>
-                    <a:bodyPr/>
-                    <a:lstStyle/>
-                    <a:p>
-                      <a:pPr algn="ctr"/>
-                      <a:r>
-                        <a:rPr lang="en-US" sz="1400" dirty="0"/>
-                        <a:t>4</a:t>
-                      </a:r>
-                    </a:p>
-                  </a:txBody>
-                  <a:tcPr marL="68580" marR="68580" marT="0" marB="0" anchor="ctr"/>
-                </a:tc>
-                <a:tc>
-                  <a:txBody>
-                    <a:bodyPr/>
-                    <a:lstStyle/>
-                    <a:p>
-                      <a:pPr algn="ctr"/>
-                      <a:r>
-                        <a:rPr lang="en-US" sz="1400" dirty="0"/>
-                        <a:t>0.27</a:t>
-                      </a:r>
-                    </a:p>
-                  </a:txBody>
-                  <a:tcPr marL="68580" marR="68580" marT="0" marB="0" anchor="ctr"/>
-                </a:tc>
-              </a:tr>
-              <a:tr h="340000">
-                <a:tc>
-                  <a:txBody>
-                    <a:bodyPr/>
-                    <a:lstStyle/>
-                    <a:p>
-                      <a:pPr algn="l"/>
-                      <a:r>
-                        <a:rPr lang="en-US" sz="1400" dirty="0"/>
-                        <a:t>3.0 &lt; X ≤ 3.5</a:t>
-                      </a:r>
-                    </a:p>
-                  </a:txBody>
-                  <a:tcPr marL="68580" marR="68580" marT="0" marB="0" anchor="ctr"/>
-                </a:tc>
-                <a:tc>
-                  <a:txBody>
-                    <a:bodyPr/>
-                    <a:lstStyle/>
-                    <a:p>
-                      <a:pPr algn="ctr"/>
-                      <a:r>
-                        <a:rPr lang="en-US" sz="1400" dirty="0"/>
-                        <a:t>3</a:t>
-                      </a:r>
-                    </a:p>
-                  </a:txBody>
-                  <a:tcPr marL="68580" marR="68580" marT="0" marB="0" anchor="ctr"/>
-                </a:tc>
-                <a:tc>
-                  <a:txBody>
-                    <a:bodyPr/>
-                    <a:lstStyle/>
-                    <a:p>
-                      <a:pPr algn="ctr"/>
-                      <a:r>
-                        <a:rPr lang="en-US" sz="1400" dirty="0"/>
-                        <a:t>0.20</a:t>
-                      </a:r>
-                    </a:p>
-                  </a:txBody>
-                  <a:tcPr marL="68580" marR="68580" marT="0" marB="0" anchor="ctr"/>
-                </a:tc>
-              </a:tr>
-              <a:tr h="340000">
-                <a:tc>
-                  <a:txBody>
-                    <a:bodyPr/>
-                    <a:lstStyle/>
-                    <a:p>
-                      <a:pPr algn="l"/>
-                      <a:r>
-                        <a:rPr lang="en-US" sz="1400" dirty="0"/>
-                        <a:t>3.5 &lt; X ≤ 4.0</a:t>
-                      </a:r>
-                    </a:p>
-                  </a:txBody>
-                  <a:tcPr marL="68580" marR="68580" marT="0" marB="0" anchor="ctr"/>
-                </a:tc>
-                <a:tc>
-                  <a:txBody>
-                    <a:bodyPr/>
-                    <a:lstStyle/>
-                    <a:p>
-                      <a:pPr algn="ctr"/>
-                      <a:r>
-                        <a:rPr lang="en-US" sz="1400" dirty="0"/>
-                        <a:t>3</a:t>
-                      </a:r>
-                    </a:p>
-                  </a:txBody>
-                  <a:tcPr marL="68580" marR="68580" marT="0" marB="0" anchor="ctr"/>
-                </a:tc>
-                <a:tc>
-                  <a:txBody>
-                    <a:bodyPr/>
-                    <a:lstStyle/>
-                    <a:p>
-                      <a:pPr algn="ctr"/>
-                      <a:r>
-                        <a:rPr lang="en-US" sz="1400" dirty="0"/>
-                        <a:t>0.20</a:t>
-                      </a:r>
-                    </a:p>
-                  </a:txBody>
-                  <a:tcPr marL="68580" marR="68580" marT="0" marB="0" anchor="ctr"/>
-                </a:tc>
-              </a:tr>
-              <a:tr h="340000">
-                <a:tc>
-                  <a:txBody>
-                    <a:bodyPr/>
-                    <a:lstStyle/>
-                    <a:p>
-                      <a:pPr algn="l"/>
-                      <a:r>
-                        <a:rPr lang="en-US" sz="1400" dirty="0"/>
-                        <a:t>4.0 &lt; X ≤ 4.5</a:t>
-                      </a:r>
-                    </a:p>
-                  </a:txBody>
-                  <a:tcPr marL="68580" marR="68580" marT="0" marB="0" anchor="ctr"/>
-                </a:tc>
-                <a:tc>
-                  <a:txBody>
-                    <a:bodyPr/>
-                    <a:lstStyle/>
-                    <a:p>
-                      <a:pPr algn="ctr"/>
-                      <a:r>
-                        <a:rPr lang="en-US" sz="1400" dirty="0"/>
-                        <a:t>2</a:t>
-                      </a:r>
-                    </a:p>
-                  </a:txBody>
-                  <a:tcPr marL="68580" marR="68580" marT="0" marB="0" anchor="ctr"/>
-                </a:tc>
-                <a:tc>
-                  <a:txBody>
-                    <a:bodyPr/>
-                    <a:lstStyle/>
-                    <a:p>
-                      <a:pPr algn="ctr"/>
-                      <a:r>
-                        <a:rPr lang="en-US" sz="1400" dirty="0"/>
-                        <a:t>0.13</a:t>
-                      </a:r>
-                    </a:p>
-                  </a:txBody>
-                  <a:tcPr marL="68580" marR="68580" marT="0" marB="0" anchor="ctr"/>
-                </a:tc>
-              </a:tr>
-              <a:tr h="340000">
+              <a:tr h="320000">
                 <a:tc>
                   <a:txBody>
                     <a:bodyPr/>
@@ -17789,6 +18256,385 @@
           </a:graphicData>
         </a:graphic>
       </p:graphicFrame>
+      <p:graphicFrame>
+        <p:nvGraphicFramePr>
+          <p:cNvPr id="6" name="Second binning"/>
+          <p:cNvGraphicFramePr>
+            <a:graphicFrameLocks noGrp="1"/>
+          </p:cNvGraphicFramePr>
+          <p:nvPr/>
+        </p:nvGraphicFramePr>
+        <p:xfrm>
+          <a:off x="6400800" y="3800000"/>
+          <a:ext cx="4100000" cy="2560000"/>
+        </p:xfrm>
+        <a:graphic>
+          <a:graphicData uri="http://schemas.openxmlformats.org/drawingml/2006/table">
+            <a:tbl>
+              <a:tblPr firstRow="1" bandRow="1">
+                <a:tableStyleId>{5C22544A-7EE6-4342-B048-85BDC9FD1C3A}</a:tableStyleId>
+              </a:tblPr>
+              <a:tblGrid>
+                <a:gridCol w="1900000"/>
+                <a:gridCol w="900000"/>
+                <a:gridCol w="1300000"/>
+              </a:tblGrid>
+              <a:tr h="320000">
+                <a:tc>
+                  <a:txBody>
+                    <a:bodyPr/>
+                    <a:lstStyle/>
+                    <a:p>
+                      <a:pPr algn="l"/>
+                      <a:r>
+                        <a:rPr lang="en-US" sz="1400" dirty="0"/>
+                        <a:t>Narrower bins</a:t>
+                      </a:r>
+                    </a:p>
+                  </a:txBody>
+                  <a:tcPr marL="68580" marR="68580" marT="0" marB="0" anchor="ctr"/>
+                </a:tc>
+                <a:tc>
+                  <a:txBody>
+                    <a:bodyPr/>
+                    <a:lstStyle/>
+                    <a:p>
+                      <a:pPr algn="ctr"/>
+                      <a:r>
+                        <a:rPr lang="en-US" sz="1400" dirty="0"/>
+                        <a:t>f</a:t>
+                      </a:r>
+                    </a:p>
+                  </a:txBody>
+                  <a:tcPr marL="68580" marR="68580" marT="0" marB="0" anchor="ctr"/>
+                </a:tc>
+                <a:tc>
+                  <a:txBody>
+                    <a:bodyPr/>
+                    <a:lstStyle/>
+                    <a:p>
+                      <a:pPr algn="ctr"/>
+                      <a:r>
+                        <a:rPr lang="en-US" sz="1400" dirty="0"/>
+                        <a:t>Rel. freq.</a:t>
+                      </a:r>
+                    </a:p>
+                  </a:txBody>
+                  <a:tcPr marL="68580" marR="68580" marT="0" marB="0" anchor="ctr"/>
+                </a:tc>
+              </a:tr>
+              <a:tr h="320000">
+                <a:tc>
+                  <a:txBody>
+                    <a:bodyPr/>
+                    <a:lstStyle/>
+                    <a:p>
+                      <a:pPr algn="l"/>
+                      <a:r>
+                        <a:rPr lang="en-US" sz="1400" dirty="0"/>
+                        <a:t>1.0 ≤ X &lt; 1.5</a:t>
+                      </a:r>
+                    </a:p>
+                  </a:txBody>
+                  <a:tcPr marL="68580" marR="68580" marT="0" marB="0" anchor="ctr"/>
+                </a:tc>
+                <a:tc>
+                  <a:txBody>
+                    <a:bodyPr/>
+                    <a:lstStyle/>
+                    <a:p>
+                      <a:pPr algn="ctr"/>
+                      <a:r>
+                        <a:rPr lang="en-US" sz="1400" dirty="0"/>
+                        <a:t>2</a:t>
+                      </a:r>
+                    </a:p>
+                  </a:txBody>
+                  <a:tcPr marL="68580" marR="68580" marT="0" marB="0" anchor="ctr"/>
+                </a:tc>
+                <a:tc>
+                  <a:txBody>
+                    <a:bodyPr/>
+                    <a:lstStyle/>
+                    <a:p>
+                      <a:pPr algn="ctr"/>
+                      <a:r>
+                        <a:rPr lang="en-US" sz="1400" dirty="0"/>
+                        <a:t>0.13</a:t>
+                      </a:r>
+                    </a:p>
+                  </a:txBody>
+                  <a:tcPr marL="68580" marR="68580" marT="0" marB="0" anchor="ctr"/>
+                </a:tc>
+              </a:tr>
+              <a:tr h="320000">
+                <a:tc>
+                  <a:txBody>
+                    <a:bodyPr/>
+                    <a:lstStyle/>
+                    <a:p>
+                      <a:pPr algn="l"/>
+                      <a:r>
+                        <a:rPr lang="en-US" sz="1400" dirty="0"/>
+                        <a:t>1.5 ≤ X &lt; 2.0</a:t>
+                      </a:r>
+                    </a:p>
+                  </a:txBody>
+                  <a:tcPr marL="68580" marR="68580" marT="0" marB="0" anchor="ctr"/>
+                </a:tc>
+                <a:tc>
+                  <a:txBody>
+                    <a:bodyPr/>
+                    <a:lstStyle/>
+                    <a:p>
+                      <a:pPr algn="ctr"/>
+                      <a:r>
+                        <a:rPr lang="en-US" sz="1400" dirty="0"/>
+                        <a:t>1</a:t>
+                      </a:r>
+                    </a:p>
+                  </a:txBody>
+                  <a:tcPr marL="68580" marR="68580" marT="0" marB="0" anchor="ctr"/>
+                </a:tc>
+                <a:tc>
+                  <a:txBody>
+                    <a:bodyPr/>
+                    <a:lstStyle/>
+                    <a:p>
+                      <a:pPr algn="ctr"/>
+                      <a:r>
+                        <a:rPr lang="en-US" sz="1400" dirty="0"/>
+                        <a:t>0.07</a:t>
+                      </a:r>
+                    </a:p>
+                  </a:txBody>
+                  <a:tcPr marL="68580" marR="68580" marT="0" marB="0" anchor="ctr"/>
+                </a:tc>
+              </a:tr>
+              <a:tr h="320000">
+                <a:tc>
+                  <a:txBody>
+                    <a:bodyPr/>
+                    <a:lstStyle/>
+                    <a:p>
+                      <a:pPr algn="l"/>
+                      <a:r>
+                        <a:rPr lang="en-US" sz="1400" dirty="0"/>
+                        <a:t>2.0 ≤ X &lt; 2.5</a:t>
+                      </a:r>
+                    </a:p>
+                  </a:txBody>
+                  <a:tcPr marL="68580" marR="68580" marT="0" marB="0" anchor="ctr"/>
+                </a:tc>
+                <a:tc>
+                  <a:txBody>
+                    <a:bodyPr/>
+                    <a:lstStyle/>
+                    <a:p>
+                      <a:pPr algn="ctr"/>
+                      <a:r>
+                        <a:rPr lang="en-US" sz="1400" dirty="0"/>
+                        <a:t>0</a:t>
+                      </a:r>
+                    </a:p>
+                  </a:txBody>
+                  <a:tcPr marL="68580" marR="68580" marT="0" marB="0" anchor="ctr"/>
+                </a:tc>
+                <a:tc>
+                  <a:txBody>
+                    <a:bodyPr/>
+                    <a:lstStyle/>
+                    <a:p>
+                      <a:pPr algn="ctr"/>
+                      <a:r>
+                        <a:rPr lang="en-US" sz="1400" dirty="0"/>
+                        <a:t>0.00</a:t>
+                      </a:r>
+                    </a:p>
+                  </a:txBody>
+                  <a:tcPr marL="68580" marR="68580" marT="0" marB="0" anchor="ctr"/>
+                </a:tc>
+              </a:tr>
+              <a:tr h="320000">
+                <a:tc>
+                  <a:txBody>
+                    <a:bodyPr/>
+                    <a:lstStyle/>
+                    <a:p>
+                      <a:pPr algn="l"/>
+                      <a:r>
+                        <a:rPr lang="en-US" sz="1400" dirty="0"/>
+                        <a:t>2.5 ≤ X &lt; 3.0</a:t>
+                      </a:r>
+                    </a:p>
+                  </a:txBody>
+                  <a:tcPr marL="68580" marR="68580" marT="0" marB="0" anchor="ctr"/>
+                </a:tc>
+                <a:tc>
+                  <a:txBody>
+                    <a:bodyPr/>
+                    <a:lstStyle/>
+                    <a:p>
+                      <a:pPr algn="ctr"/>
+                      <a:r>
+                        <a:rPr lang="en-US" sz="1400" dirty="0"/>
+                        <a:t>4</a:t>
+                      </a:r>
+                    </a:p>
+                  </a:txBody>
+                  <a:tcPr marL="68580" marR="68580" marT="0" marB="0" anchor="ctr"/>
+                </a:tc>
+                <a:tc>
+                  <a:txBody>
+                    <a:bodyPr/>
+                    <a:lstStyle/>
+                    <a:p>
+                      <a:pPr algn="ctr"/>
+                      <a:r>
+                        <a:rPr lang="en-US" sz="1400" dirty="0"/>
+                        <a:t>0.27</a:t>
+                      </a:r>
+                    </a:p>
+                  </a:txBody>
+                  <a:tcPr marL="68580" marR="68580" marT="0" marB="0" anchor="ctr"/>
+                </a:tc>
+              </a:tr>
+              <a:tr h="320000">
+                <a:tc>
+                  <a:txBody>
+                    <a:bodyPr/>
+                    <a:lstStyle/>
+                    <a:p>
+                      <a:pPr algn="l"/>
+                      <a:r>
+                        <a:rPr lang="en-US" sz="1400" dirty="0"/>
+                        <a:t>3.0 ≤ X &lt; 3.5</a:t>
+                      </a:r>
+                    </a:p>
+                  </a:txBody>
+                  <a:tcPr marL="68580" marR="68580" marT="0" marB="0" anchor="ctr"/>
+                </a:tc>
+                <a:tc>
+                  <a:txBody>
+                    <a:bodyPr/>
+                    <a:lstStyle/>
+                    <a:p>
+                      <a:pPr algn="ctr"/>
+                      <a:r>
+                        <a:rPr lang="en-US" sz="1400" dirty="0"/>
+                        <a:t>3</a:t>
+                      </a:r>
+                    </a:p>
+                  </a:txBody>
+                  <a:tcPr marL="68580" marR="68580" marT="0" marB="0" anchor="ctr"/>
+                </a:tc>
+                <a:tc>
+                  <a:txBody>
+                    <a:bodyPr/>
+                    <a:lstStyle/>
+                    <a:p>
+                      <a:pPr algn="ctr"/>
+                      <a:r>
+                        <a:rPr lang="en-US" sz="1400" dirty="0"/>
+                        <a:t>0.20</a:t>
+                      </a:r>
+                    </a:p>
+                  </a:txBody>
+                  <a:tcPr marL="68580" marR="68580" marT="0" marB="0" anchor="ctr"/>
+                </a:tc>
+              </a:tr>
+              <a:tr h="320000">
+                <a:tc>
+                  <a:txBody>
+                    <a:bodyPr/>
+                    <a:lstStyle/>
+                    <a:p>
+                      <a:pPr algn="l"/>
+                      <a:r>
+                        <a:rPr lang="en-US" sz="1400" dirty="0"/>
+                        <a:t>3.5 ≤ X &lt; 4.0</a:t>
+                      </a:r>
+                    </a:p>
+                  </a:txBody>
+                  <a:tcPr marL="68580" marR="68580" marT="0" marB="0" anchor="ctr"/>
+                </a:tc>
+                <a:tc>
+                  <a:txBody>
+                    <a:bodyPr/>
+                    <a:lstStyle/>
+                    <a:p>
+                      <a:pPr algn="ctr"/>
+                      <a:r>
+                        <a:rPr lang="en-US" sz="1400" dirty="0"/>
+                        <a:t>3</a:t>
+                      </a:r>
+                    </a:p>
+                  </a:txBody>
+                  <a:tcPr marL="68580" marR="68580" marT="0" marB="0" anchor="ctr"/>
+                </a:tc>
+                <a:tc>
+                  <a:txBody>
+                    <a:bodyPr/>
+                    <a:lstStyle/>
+                    <a:p>
+                      <a:pPr algn="ctr"/>
+                      <a:r>
+                        <a:rPr lang="en-US" sz="1400" dirty="0"/>
+                        <a:t>0.20</a:t>
+                      </a:r>
+                    </a:p>
+                  </a:txBody>
+                  <a:tcPr marL="68580" marR="68580" marT="0" marB="0" anchor="ctr"/>
+                </a:tc>
+              </a:tr>
+              <a:tr h="320000">
+                <a:tc>
+                  <a:txBody>
+                    <a:bodyPr/>
+                    <a:lstStyle/>
+                    <a:p>
+                      <a:pPr algn="l"/>
+                      <a:r>
+                        <a:rPr lang="en-US" sz="1400" dirty="0"/>
+                        <a:t>4.0 ≤ X &lt; 4.5</a:t>
+                      </a:r>
+                    </a:p>
+                  </a:txBody>
+                  <a:tcPr marL="68580" marR="68580" marT="0" marB="0" anchor="ctr"/>
+                </a:tc>
+                <a:tc>
+                  <a:txBody>
+                    <a:bodyPr/>
+                    <a:lstStyle/>
+                    <a:p>
+                      <a:pPr algn="ctr"/>
+                      <a:r>
+                        <a:rPr lang="en-US" sz="1400" dirty="0"/>
+                        <a:t>2</a:t>
+                      </a:r>
+                    </a:p>
+                  </a:txBody>
+                  <a:tcPr marL="68580" marR="68580" marT="0" marB="0" anchor="ctr"/>
+                </a:tc>
+                <a:tc>
+                  <a:txBody>
+                    <a:bodyPr/>
+                    <a:lstStyle/>
+                    <a:p>
+                      <a:pPr algn="ctr"/>
+                      <a:r>
+                        <a:rPr lang="en-US" sz="1400" dirty="0"/>
+                        <a:t>0.13</a:t>
+                      </a:r>
+                    </a:p>
+                  </a:txBody>
+                  <a:tcPr marL="68580" marR="68580" marT="0" marB="0" anchor="ctr"/>
+                </a:tc>
+              </a:tr>
+            </a:tbl>
+          </a:graphicData>
+        </a:graphic>
+      </p:graphicFrame>
       <p:sp>
         <p:nvSpPr>
           <p:cNvPr id="5" name="Takeaway"/>
@@ -17797,8 +18643,8 @@
         </p:nvSpPr>
         <p:spPr>
           <a:xfrm>
-            <a:off x="6400800" y="5020000"/>
-            <a:ext cx="4300000" cy="1400000"/>
+            <a:off x="838200" y="4150000"/>
+            <a:ext cx="5250000" cy="1900000"/>
           </a:xfrm>
           <a:prstGeom prst="rect">
             <a:avLst/>
@@ -17806,7 +18652,7 @@
           <a:noFill/>
         </p:spPr>
         <p:txBody>
-          <a:bodyPr wrap="square">
+          <a:bodyPr wrap="square" lIns="0" tIns="0" rIns="0" bIns="0">
             <a:normAutofit/>
           </a:bodyPr>
           <a:lstStyle/>
@@ -17820,7 +18666,23 @@
                   <a:srgbClr val="C00000"/>
                 </a:solidFill>
               </a:rPr>
-              <a:t>The empty bin is information: the values fall into two clusters. Next, the same procedure on real data – 272 Old Faithful eruptions.</a:t>
+              <a:t>Bin width is a choice, not a property of the data. Halving it splits the middle and exposes an empty bin: the values fall into two clusters.</a:t>
+            </a:r>
+          </a:p>
+          <a:p>
+            <a:pPr marL="0" indent="0">
+              <a:spcBef>
+                <a:spcPts val="400"/>
+              </a:spcBef>
+              <a:buNone/>
+            </a:pPr>
+            <a:r>
+              <a:rPr lang="en-US" sz="1500" b="1" dirty="0">
+                <a:solidFill>
+                  <a:srgbClr val="C00000"/>
+                </a:solidFill>
+              </a:rPr>
+              <a:t>Next: the same procedure on 272 Old Faithful eruptions.</a:t>
             </a:r>
           </a:p>
         </p:txBody>
@@ -17828,7 +18690,7 @@
     </p:spTree>
     <p:extLst>
       <p:ext uri="{BB962C8B-B14F-4D97-AF65-F5344CB8AC3E}">
-        <p14:creationId xmlns:p14="http://schemas.microsoft.com/office/powerpoint/2010/main" val="1517484005"/>
+        <p14:creationId xmlns:p14="http://schemas.microsoft.com/office/powerpoint/2010/main" val="1517484023"/>
       </p:ext>
     </p:extLst>
   </p:cSld>
@@ -17914,6 +18776,51 @@
                                           </p:stCondLst>
                                         </p:cTn>
                                         <p:tgtEl>
+                                          <p:spTgt spid="6"/>
+                                        </p:tgtEl>
+                                        <p:attrNameLst>
+                                          <p:attrName>style.visibility</p:attrName>
+                                        </p:attrNameLst>
+                                      </p:cBhvr>
+                                      <p:to>
+                                        <p:strVal val="visible"/>
+                                      </p:to>
+                                    </p:set>
+                                  </p:childTnLst>
+                                </p:cTn>
+                              </p:par>
+                            </p:childTnLst>
+                          </p:cTn>
+                        </p:par>
+                      </p:childTnLst>
+                    </p:cTn>
+                  </p:par>
+                  <p:par>
+                    <p:cTn id="11" fill="hold">
+                      <p:stCondLst>
+                        <p:cond delay="indefinite"/>
+                      </p:stCondLst>
+                      <p:childTnLst>
+                        <p:par>
+                          <p:cTn id="12" fill="hold">
+                            <p:stCondLst>
+                              <p:cond delay="0"/>
+                            </p:stCondLst>
+                            <p:childTnLst>
+                              <p:par>
+                                <p:cTn id="13" presetID="1" presetClass="entr" presetSubtype="0" fill="hold" nodeType="clickEffect">
+                                  <p:stCondLst>
+                                    <p:cond delay="0"/>
+                                  </p:stCondLst>
+                                  <p:childTnLst>
+                                    <p:set>
+                                      <p:cBhvr>
+                                        <p:cTn id="14" dur="1" fill="hold">
+                                          <p:stCondLst>
+                                            <p:cond delay="0"/>
+                                          </p:stCondLst>
+                                        </p:cTn>
+                                        <p:tgtEl>
                                           <p:spTgt spid="5"/>
                                         </p:tgtEl>
                                         <p:attrNameLst>
@@ -18007,8 +18914,8 @@
         </p:nvSpPr>
         <p:spPr>
           <a:xfrm>
-            <a:off x="1200150" y="1600200"/>
-            <a:ext cx="9800000" cy="800000"/>
+            <a:off x="838200" y="1560000"/>
+            <a:ext cx="10515600" cy="700000"/>
           </a:xfrm>
           <a:prstGeom prst="rect">
             <a:avLst/>
@@ -18016,7 +18923,7 @@
           <a:noFill/>
         </p:spPr>
         <p:txBody>
-          <a:bodyPr wrap="square">
+          <a:bodyPr wrap="square" lIns="0" tIns="0" rIns="0" bIns="0">
             <a:normAutofit/>
           </a:bodyPr>
           <a:lstStyle/>
@@ -18025,7 +18932,7 @@
               <a:buNone/>
             </a:pPr>
             <a:r>
-              <a:rPr lang="en-US" sz="1800" dirty="0"/>
+              <a:rPr lang="en-US" sz="1700" dirty="0"/>
               <a:t>In one of Gregor Mendel’s classic studies he bred 8,023 pea plants and recorded the color of the peas – the seeds – that each plant produced.</a:t>
             </a:r>
           </a:p>
@@ -18047,8 +18954,8 @@
         </p:blipFill>
         <p:spPr>
           <a:xfrm>
-            <a:off x="2438400" y="2620000"/>
-            <a:ext cx="7315200" cy="2479040"/>
+            <a:off x="838200" y="2750000"/>
+            <a:ext cx="5486400" cy="1859664"/>
           </a:xfrm>
           <a:prstGeom prst="rect">
             <a:avLst/>
@@ -18057,14 +18964,103 @@
       </p:pic>
       <p:sp>
         <p:nvSpPr>
-          <p:cNvPr id="5" name="Payoff"/>
+          <p:cNvPr id="5" name="Genetics"/>
+          <p:cNvSpPr/>
+          <p:nvPr/>
+        </p:nvSpPr>
+        <p:spPr>
+          <a:xfrm>
+            <a:off x="6650000" y="2420000"/>
+            <a:ext cx="4703800" cy="2550000"/>
+          </a:xfrm>
+          <a:prstGeom prst="roundRect">
+            <a:avLst>
+              <a:gd name="adj" fmla="val 4000"/>
+            </a:avLst>
+          </a:prstGeom>
+          <a:solidFill>
+            <a:srgbClr val="F2F6FC"/>
+          </a:solidFill>
+          <a:ln w="19050">
+            <a:solidFill>
+              <a:schemeClr val="accent1"/>
+            </a:solidFill>
+          </a:ln>
+        </p:spPr>
+        <p:txBody>
+          <a:bodyPr lIns="205740" tIns="160020" rIns="205740" bIns="114300">
+            <a:normAutofit/>
+          </a:bodyPr>
+          <a:lstStyle/>
+          <a:p>
+            <a:pPr marL="0" indent="0">
+              <a:buNone/>
+            </a:pPr>
+            <a:r>
+              <a:rPr lang="en-US" sz="1600" b="1" dirty="0"/>
+              <a:t>Pea color is set by a single gene.</a:t>
+            </a:r>
+          </a:p>
+          <a:p>
+            <a:pPr marL="0" indent="0">
+              <a:spcBef>
+                <a:spcPts val="400"/>
+              </a:spcBef>
+              <a:buNone/>
+            </a:pPr>
+            <a:r>
+              <a:rPr lang="en-US" sz="1600" dirty="0"/>
+              <a:t>Yellow (Y) is </a:t>
+            </a:r>
+            <a:r>
+              <a:rPr lang="en-US" sz="1600" b="1" dirty="0">
+                <a:solidFill>
+                  <a:srgbClr val="4472C4"/>
+                </a:solidFill>
+              </a:rPr>
+              <a:t>dominant</a:t>
+            </a:r>
+            <a:r>
+              <a:rPr lang="en-US" sz="1600" dirty="0"/>
+              <a:t>; green (y) is </a:t>
+            </a:r>
+            <a:r>
+              <a:rPr lang="en-US" sz="1600" b="1" dirty="0">
+                <a:solidFill>
+                  <a:srgbClr val="4472C4"/>
+                </a:solidFill>
+              </a:rPr>
+              <a:t>recessive</a:t>
+            </a:r>
+            <a:r>
+              <a:rPr lang="en-US" sz="1600" dirty="0"/>
+              <a:t>. A plant is green only if it inherits y from both parents.</a:t>
+            </a:r>
+          </a:p>
+          <a:p>
+            <a:pPr marL="0" indent="0">
+              <a:spcBef>
+                <a:spcPts val="400"/>
+              </a:spcBef>
+              <a:buNone/>
+            </a:pPr>
+            <a:r>
+              <a:rPr lang="en-US" sz="1600" dirty="0"/>
+              <a:t>Cross two Yy plants and the offspring are YY, Yy, yY, yy in equal proportion – and only yy shows green. So the theory predicts 3 yellow to every 1 green.</a:t>
+            </a:r>
+          </a:p>
+        </p:txBody>
+      </p:sp>
+      <p:sp>
+        <p:nvSpPr>
+          <p:cNvPr id="6" name="Payoff"/>
           <p:cNvSpPr txBox="1"/>
           <p:nvPr/>
         </p:nvSpPr>
         <p:spPr>
           <a:xfrm>
-            <a:off x="1200150" y="5300000"/>
-            <a:ext cx="9800000" cy="900000"/>
+            <a:off x="838200" y="5450000"/>
+            <a:ext cx="10515600" cy="900000"/>
           </a:xfrm>
           <a:prstGeom prst="rect">
             <a:avLst/>
@@ -18072,7 +19068,7 @@
           <a:noFill/>
         </p:spPr>
         <p:txBody>
-          <a:bodyPr wrap="square">
+          <a:bodyPr wrap="square" lIns="0" tIns="0" rIns="0" bIns="0">
             <a:normAutofit/>
           </a:bodyPr>
           <a:lstStyle/>
@@ -18081,12 +19077,12 @@
               <a:buNone/>
             </a:pPr>
             <a:r>
-              <a:rPr lang="en-US" sz="1800" b="1" dirty="0">
+              <a:rPr lang="en-US" sz="1700" b="1" dirty="0">
                 <a:solidFill>
                   <a:srgbClr val="C00000"/>
                 </a:solidFill>
               </a:rPr>
-              <a:t>The relative frequencies are almost exactly 3/4 and 1/4 – the 3:1 ratio Mendel’s theory of inheritance predicts. A frequency table is doing real scientific work here.</a:t>
+              <a:t>Mendel counted 0.751 and 0.249 – almost exactly 3/4 and 1/4. A frequency table is doing real scientific work here.</a:t>
             </a:r>
           </a:p>
         </p:txBody>
@@ -18094,7 +19090,7 @@
     </p:spTree>
     <p:extLst>
       <p:ext uri="{BB962C8B-B14F-4D97-AF65-F5344CB8AC3E}">
-        <p14:creationId xmlns:p14="http://schemas.microsoft.com/office/powerpoint/2010/main" val="1517484006"/>
+        <p14:creationId xmlns:p14="http://schemas.microsoft.com/office/powerpoint/2010/main" val="1517484021"/>
       </p:ext>
     </p:extLst>
   </p:cSld>
@@ -18136,6 +19132,51 @@
                                         </p:cTn>
                                         <p:tgtEl>
                                           <p:spTgt spid="5"/>
+                                        </p:tgtEl>
+                                        <p:attrNameLst>
+                                          <p:attrName>style.visibility</p:attrName>
+                                        </p:attrNameLst>
+                                      </p:cBhvr>
+                                      <p:to>
+                                        <p:strVal val="visible"/>
+                                      </p:to>
+                                    </p:set>
+                                  </p:childTnLst>
+                                </p:cTn>
+                              </p:par>
+                            </p:childTnLst>
+                          </p:cTn>
+                        </p:par>
+                      </p:childTnLst>
+                    </p:cTn>
+                  </p:par>
+                  <p:par>
+                    <p:cTn id="7" fill="hold">
+                      <p:stCondLst>
+                        <p:cond delay="indefinite"/>
+                      </p:stCondLst>
+                      <p:childTnLst>
+                        <p:par>
+                          <p:cTn id="8" fill="hold">
+                            <p:stCondLst>
+                              <p:cond delay="0"/>
+                            </p:stCondLst>
+                            <p:childTnLst>
+                              <p:par>
+                                <p:cTn id="9" presetID="1" presetClass="entr" presetSubtype="0" fill="hold" nodeType="clickEffect">
+                                  <p:stCondLst>
+                                    <p:cond delay="0"/>
+                                  </p:stCondLst>
+                                  <p:childTnLst>
+                                    <p:set>
+                                      <p:cBhvr>
+                                        <p:cTn id="10" dur="1" fill="hold">
+                                          <p:stCondLst>
+                                            <p:cond delay="0"/>
+                                          </p:stCondLst>
+                                        </p:cTn>
+                                        <p:tgtEl>
+                                          <p:spTgt spid="6"/>
                                         </p:tgtEl>
                                         <p:attrNameLst>
                                           <p:attrName>style.visibility</p:attrName>
@@ -18228,8 +19269,8 @@
         </p:nvSpPr>
         <p:spPr>
           <a:xfrm>
-            <a:off x="838200" y="1650000"/>
-            <a:ext cx="10515600" cy="1450000"/>
+            <a:off x="838200" y="1560000"/>
+            <a:ext cx="10515600" cy="1230000"/>
           </a:xfrm>
           <a:prstGeom prst="roundRect">
             <a:avLst>
@@ -18255,7 +19296,7 @@
               <a:buNone/>
             </a:pPr>
             <a:r>
-              <a:rPr lang="en-US" sz="1800" b="1" dirty="0">
+              <a:rPr lang="en-US" sz="1700" b="1" dirty="0">
                 <a:solidFill>
                   <a:srgbClr val="4472C4"/>
                 </a:solidFill>
@@ -18263,8 +19304,8 @@
               <a:t>1   </a:t>
             </a:r>
             <a:r>
-              <a:rPr lang="en-US" sz="1800" b="1" dirty="0"/>
-              <a:t>What are the three arms of statistics?</a:t>
+              <a:rPr lang="en-US" sz="1700" b="1" dirty="0"/>
+              <a:t>What do we call the way we collect the data?</a:t>
             </a:r>
           </a:p>
         </p:txBody>
@@ -18277,8 +19318,8 @@
         </p:nvSpPr>
         <p:spPr>
           <a:xfrm>
-            <a:off x="1066800" y="2290000"/>
-            <a:ext cx="10058400" cy="718560"/>
+            <a:off x="1066800" y="2140000"/>
+            <a:ext cx="10058400" cy="558560"/>
           </a:xfrm>
           <a:prstGeom prst="rect">
             <a:avLst/>
@@ -18295,12 +19336,12 @@
               <a:buNone/>
             </a:pPr>
             <a:r>
-              <a:rPr lang="en-US" sz="1600" dirty="0">
+              <a:rPr lang="en-US" sz="1500" dirty="0">
                 <a:solidFill>
                   <a:srgbClr val="C00000"/>
                 </a:solidFill>
               </a:rPr>
-              <a:t>Design, description and inference.</a:t>
+              <a:t>The sampling design.</a:t>
             </a:r>
           </a:p>
         </p:txBody>
@@ -18313,8 +19354,8 @@
         </p:nvSpPr>
         <p:spPr>
           <a:xfrm>
-            <a:off x="838200" y="3300000"/>
-            <a:ext cx="10515600" cy="1450000"/>
+            <a:off x="838200" y="2870000"/>
+            <a:ext cx="10515600" cy="1230000"/>
           </a:xfrm>
           <a:prstGeom prst="roundRect">
             <a:avLst>
@@ -18340,7 +19381,7 @@
               <a:buNone/>
             </a:pPr>
             <a:r>
-              <a:rPr lang="en-US" sz="1800" b="1" dirty="0">
+              <a:rPr lang="en-US" sz="1700" b="1" dirty="0">
                 <a:solidFill>
                   <a:srgbClr val="4472C4"/>
                 </a:solidFill>
@@ -18348,8 +19389,8 @@
               <a:t>2   </a:t>
             </a:r>
             <a:r>
-              <a:rPr lang="en-US" sz="1800" b="1" dirty="0"/>
-              <a:t>Which one comes first, and why?</a:t>
+              <a:rPr lang="en-US" sz="1700" b="1" dirty="0"/>
+              <a:t>What are the three arms of statistics?</a:t>
             </a:r>
           </a:p>
         </p:txBody>
@@ -18362,8 +19403,8 @@
         </p:nvSpPr>
         <p:spPr>
           <a:xfrm>
-            <a:off x="1066800" y="3940000"/>
-            <a:ext cx="10058400" cy="718560"/>
+            <a:off x="1066800" y="3450000"/>
+            <a:ext cx="10058400" cy="558560"/>
           </a:xfrm>
           <a:prstGeom prst="rect">
             <a:avLst/>
@@ -18380,12 +19421,12 @@
               <a:buNone/>
             </a:pPr>
             <a:r>
-              <a:rPr lang="en-US" sz="1600" dirty="0">
+              <a:rPr lang="en-US" sz="1500" dirty="0">
                 <a:solidFill>
                   <a:srgbClr val="C00000"/>
                 </a:solidFill>
               </a:rPr>
-              <a:t>Design – how we plan to collect the data, settled before any data exists. No amount of description or inference repairs a bad design.</a:t>
+              <a:t>Design, description and inference.</a:t>
             </a:r>
           </a:p>
         </p:txBody>
@@ -18398,8 +19439,8 @@
         </p:nvSpPr>
         <p:spPr>
           <a:xfrm>
-            <a:off x="838200" y="4950000"/>
-            <a:ext cx="10515600" cy="1450000"/>
+            <a:off x="838200" y="4180000"/>
+            <a:ext cx="10515600" cy="1230000"/>
           </a:xfrm>
           <a:prstGeom prst="roundRect">
             <a:avLst>
@@ -18425,7 +19466,7 @@
               <a:buNone/>
             </a:pPr>
             <a:r>
-              <a:rPr lang="en-US" sz="1800" b="1" dirty="0">
+              <a:rPr lang="en-US" sz="1700" b="1" dirty="0">
                 <a:solidFill>
                   <a:srgbClr val="4472C4"/>
                 </a:solidFill>
@@ -18433,8 +19474,8 @@
               <a:t>3   </a:t>
             </a:r>
             <a:r>
-              <a:rPr lang="en-US" sz="1800" b="1" dirty="0"/>
-              <a:t>What is an estimate?</a:t>
+              <a:rPr lang="en-US" sz="1700" b="1" dirty="0"/>
+              <a:t>Which one comes first, and why?</a:t>
             </a:r>
           </a:p>
         </p:txBody>
@@ -18447,8 +19488,8 @@
         </p:nvSpPr>
         <p:spPr>
           <a:xfrm>
-            <a:off x="1066800" y="5590000"/>
-            <a:ext cx="10058400" cy="718560"/>
+            <a:off x="1066800" y="4760000"/>
+            <a:ext cx="10058400" cy="558560"/>
           </a:xfrm>
           <a:prstGeom prst="rect">
             <a:avLst/>
@@ -18465,7 +19506,92 @@
               <a:buNone/>
             </a:pPr>
             <a:r>
-              <a:rPr lang="en-US" sz="1600" dirty="0">
+              <a:rPr lang="en-US" sz="1500" dirty="0">
+                <a:solidFill>
+                  <a:srgbClr val="C00000"/>
+                </a:solidFill>
+              </a:rPr>
+              <a:t>Design – how we plan to collect the data, settled before any data exists. No amount of description or inference repairs a bad design.</a:t>
+            </a:r>
+          </a:p>
+        </p:txBody>
+      </p:sp>
+      <p:sp>
+        <p:nvSpPr>
+          <p:cNvPr id="9" name="Question 4"/>
+          <p:cNvSpPr/>
+          <p:nvPr/>
+        </p:nvSpPr>
+        <p:spPr>
+          <a:xfrm>
+            <a:off x="838200" y="5490000"/>
+            <a:ext cx="10515600" cy="1230000"/>
+          </a:xfrm>
+          <a:prstGeom prst="roundRect">
+            <a:avLst>
+              <a:gd name="adj" fmla="val 4000"/>
+            </a:avLst>
+          </a:prstGeom>
+          <a:solidFill>
+            <a:srgbClr val="F2F6FC"/>
+          </a:solidFill>
+          <a:ln w="19050">
+            <a:solidFill>
+              <a:schemeClr val="accent1"/>
+            </a:solidFill>
+          </a:ln>
+        </p:spPr>
+        <p:txBody>
+          <a:bodyPr lIns="228600" tIns="182880" rIns="228600" bIns="91440" anchor="t">
+            <a:normAutofit/>
+          </a:bodyPr>
+          <a:lstStyle/>
+          <a:p>
+            <a:pPr marL="0" indent="0">
+              <a:buNone/>
+            </a:pPr>
+            <a:r>
+              <a:rPr lang="en-US" sz="1700" b="1" dirty="0">
+                <a:solidFill>
+                  <a:srgbClr val="4472C4"/>
+                </a:solidFill>
+              </a:rPr>
+              <a:t>4   </a:t>
+            </a:r>
+            <a:r>
+              <a:rPr lang="en-US" sz="1700" b="1" dirty="0"/>
+              <a:t>What is an estimate?</a:t>
+            </a:r>
+          </a:p>
+        </p:txBody>
+      </p:sp>
+      <p:sp>
+        <p:nvSpPr>
+          <p:cNvPr id="10" name="Answer 4"/>
+          <p:cNvSpPr txBox="1"/>
+          <p:nvPr/>
+        </p:nvSpPr>
+        <p:spPr>
+          <a:xfrm>
+            <a:off x="1066800" y="6070000"/>
+            <a:ext cx="10058400" cy="558560"/>
+          </a:xfrm>
+          <a:prstGeom prst="rect">
+            <a:avLst/>
+          </a:prstGeom>
+          <a:noFill/>
+        </p:spPr>
+        <p:txBody>
+          <a:bodyPr wrap="square" lIns="0" tIns="0" rIns="0" bIns="0">
+            <a:normAutofit/>
+          </a:bodyPr>
+          <a:lstStyle/>
+          <a:p>
+            <a:pPr marL="0" indent="0">
+              <a:buNone/>
+            </a:pPr>
+            <a:r>
+              <a:rPr lang="en-US" sz="1500" dirty="0">
                 <a:solidFill>
                   <a:srgbClr val="C00000"/>
                 </a:solidFill>
@@ -18745,6 +19871,96 @@
                                         </p:cTn>
                                         <p:tgtEl>
                                           <p:spTgt spid="8"/>
+                                        </p:tgtEl>
+                                        <p:attrNameLst>
+                                          <p:attrName>style.visibility</p:attrName>
+                                        </p:attrNameLst>
+                                      </p:cBhvr>
+                                      <p:to>
+                                        <p:strVal val="visible"/>
+                                      </p:to>
+                                    </p:set>
+                                  </p:childTnLst>
+                                </p:cTn>
+                              </p:par>
+                            </p:childTnLst>
+                          </p:cTn>
+                        </p:par>
+                      </p:childTnLst>
+                    </p:cTn>
+                  </p:par>
+                  <p:par>
+                    <p:cTn id="27" fill="hold">
+                      <p:stCondLst>
+                        <p:cond delay="indefinite"/>
+                      </p:stCondLst>
+                      <p:childTnLst>
+                        <p:par>
+                          <p:cTn id="28" fill="hold">
+                            <p:stCondLst>
+                              <p:cond delay="0"/>
+                            </p:stCondLst>
+                            <p:childTnLst>
+                              <p:par>
+                                <p:cTn id="29" presetID="1" presetClass="entr" presetSubtype="0" fill="hold" nodeType="clickEffect">
+                                  <p:stCondLst>
+                                    <p:cond delay="0"/>
+                                  </p:stCondLst>
+                                  <p:childTnLst>
+                                    <p:set>
+                                      <p:cBhvr>
+                                        <p:cTn id="30" dur="1" fill="hold">
+                                          <p:stCondLst>
+                                            <p:cond delay="0"/>
+                                          </p:stCondLst>
+                                        </p:cTn>
+                                        <p:tgtEl>
+                                          <p:spTgt spid="9"/>
+                                        </p:tgtEl>
+                                        <p:attrNameLst>
+                                          <p:attrName>style.visibility</p:attrName>
+                                        </p:attrNameLst>
+                                      </p:cBhvr>
+                                      <p:to>
+                                        <p:strVal val="visible"/>
+                                      </p:to>
+                                    </p:set>
+                                  </p:childTnLst>
+                                </p:cTn>
+                              </p:par>
+                            </p:childTnLst>
+                          </p:cTn>
+                        </p:par>
+                      </p:childTnLst>
+                    </p:cTn>
+                  </p:par>
+                  <p:par>
+                    <p:cTn id="31" fill="hold">
+                      <p:stCondLst>
+                        <p:cond delay="indefinite"/>
+                      </p:stCondLst>
+                      <p:childTnLst>
+                        <p:par>
+                          <p:cTn id="32" fill="hold">
+                            <p:stCondLst>
+                              <p:cond delay="0"/>
+                            </p:stCondLst>
+                            <p:childTnLst>
+                              <p:par>
+                                <p:cTn id="33" presetID="1" presetClass="entr" presetSubtype="0" fill="hold" nodeType="clickEffect">
+                                  <p:stCondLst>
+                                    <p:cond delay="0"/>
+                                  </p:stCondLst>
+                                  <p:childTnLst>
+                                    <p:set>
+                                      <p:cBhvr>
+                                        <p:cTn id="34" dur="1" fill="hold">
+                                          <p:stCondLst>
+                                            <p:cond delay="0"/>
+                                          </p:stCondLst>
+                                        </p:cTn>
+                                        <p:tgtEl>
+                                          <p:spTgt spid="10"/>
                                         </p:tgtEl>
                                         <p:attrNameLst>
                                           <p:attrName>style.visibility</p:attrName>

</xml_diff>

<commit_message>
Update Week 2 lecture 3 slides
Refresh the Week 2 Lecture 3 PDF and PowerPoint deck to the latest version. This also removes the temporary Office lock file created while editing the slide deck.
</commit_message>
<xml_diff>
--- a/docs/lecture_slides/Week 2/Week2_Lecture3_Slides_1_19_2024.pptx
+++ b/docs/lecture_slides/Week 2/Week2_Lecture3_Slides_1_19_2024.pptx
@@ -17,12 +17,12 @@
     <p:sldId id="342" r:id="rId11"/>
     <p:sldId id="346" r:id="rId12"/>
     <p:sldId id="343" r:id="rId13"/>
-    <p:sldId id="330" r:id="rId14"/>
     <p:sldId id="344" r:id="rId15"/>
     <p:sldId id="286" r:id="rId16"/>
     <p:sldId id="345" r:id="rId17"/>
     <p:sldId id="273" r:id="rId18"/>
     <p:sldId id="288" r:id="rId19"/>
+    <p:sldId id="330" r:id="rId14"/>
     <p:sldId id="277" r:id="rId20"/>
     <p:sldId id="287" r:id="rId21"/>
     <p:sldId id="282" r:id="rId22"/>
@@ -6797,7 +6797,7 @@
       </p:sp>
       <p:pic>
         <p:nvPicPr>
-          <p:cNvPr id="30" name="Table stage 1">
+          <p:cNvPr id="30" name="Table stage 1" descr="Frequency table of the teen survey showing the Response and Frequency columns only: Never 289, Rarely 216, Sometimes 178, Often 60, total 743.">
             <a:extLst>
               <a:ext uri="{FF2B5EF4-FFF2-40B4-BE49-F238E27FC236}">
                 <a16:creationId xmlns:a16="http://schemas.microsoft.com/office/drawing/2014/main" id="{A726F141-28A4-5B62-1A80-B214989D15D2}"/>
@@ -6827,7 +6827,7 @@
       </p:pic>
       <p:pic>
         <p:nvPicPr>
-          <p:cNvPr id="31" name="Table stage 2">
+          <p:cNvPr id="31" name="Table stage 2" descr="The same frequency table with a Relative Frequency column added: 0.39, 0.29, 0.24, 0.08, totalling 1.00.">
             <a:extLst>
               <a:ext uri="{FF2B5EF4-FFF2-40B4-BE49-F238E27FC236}">
                 <a16:creationId xmlns:a16="http://schemas.microsoft.com/office/drawing/2014/main" id="{A726F141-28A4-5B62-1A80-B214989D15D2}"/>
@@ -6857,7 +6857,7 @@
       </p:pic>
       <p:pic>
         <p:nvPicPr>
-          <p:cNvPr id="9" name="Picture 8">
+          <p:cNvPr id="9" name="Picture 8" descr="The completed frequency table with a Cumulative Relative Frequency column added: 0.39, 0.68, 0.92, 1.00.">
             <a:extLst>
               <a:ext uri="{FF2B5EF4-FFF2-40B4-BE49-F238E27FC236}">
                 <a16:creationId xmlns:a16="http://schemas.microsoft.com/office/drawing/2014/main" id="{A726F141-28A4-5B62-1A80-B214989D15D2}"/>
@@ -7155,7 +7155,7 @@
       </p:sp>
       <p:pic>
         <p:nvPicPr>
-          <p:cNvPr id="4" name="Mendel table"/>
+          <p:cNvPr id="4" name="Mendel table" descr="Frequency table of Mendel's pea colours: yellow 6022 with relative frequency 0.751, green 2001 with relative frequency 0.249, out of 8,023 plants - close to three yellow for every one green."/>
           <p:cNvPicPr>
             <a:picLocks noChangeAspect="1"/>
           </p:cNvPicPr>
@@ -7569,7 +7569,7 @@
       </p:sp>
       <p:graphicFrame>
         <p:nvGraphicFramePr>
-          <p:cNvPr id="4" name="Answer table"/>
+          <p:cNvPr id="4" name="Answer table" descr="Frequency table for the twenty class responses: Never 7 (0.35, 0.35), Rarely 6 (0.30, 0.65), Sometimes 5 (0.25, 0.90), Often 2 (0.10, 1.00), total 20."/>
           <p:cNvGraphicFramePr>
             <a:graphicFrameLocks noGrp="1"/>
           </p:cNvGraphicFramePr>
@@ -8182,6 +8182,35 @@
       </p:grpSpPr>
       <p:sp>
         <p:nvSpPr>
+          <p:cNvPr id="900" name="Title 1"/>
+          <p:cNvSpPr>
+            <a:spLocks noGrp="1"/>
+          </p:cNvSpPr>
+          <p:nvPr>
+            <p:ph type="title"/>
+          </p:nvPr>
+        </p:nvSpPr>
+        <p:spPr>
+          <a:xfrm>
+            <a:off x="-8000000" y="0"/>
+            <a:ext cx="6000000" cy="800000"/>
+          </a:xfrm>
+        </p:spPr>
+        <p:txBody>
+          <a:bodyPr>
+            <a:normAutofit/>
+          </a:bodyPr>
+          <a:lstStyle/>
+          <a:p>
+            <a:r>
+              <a:rPr lang="en-US" sz="1800" dirty="0"/>
+              <a:t>Graphical descriptions of data</a:t>
+            </a:r>
+          </a:p>
+        </p:txBody>
+      </p:sp>
+      <p:sp>
+        <p:nvSpPr>
           <p:cNvPr id="6" name="Rectangle: Rounded Corners 5">
             <a:extLst>
               <a:ext uri="{FF2B5EF4-FFF2-40B4-BE49-F238E27FC236}">
@@ -8617,7 +8646,7 @@
             </a:pPr>
             <a:r>
               <a:rPr lang="en-US" dirty="0"/>
-              <a:t>Spread</a:t>
+              <a:t>Variability</a:t>
             </a:r>
           </a:p>
         </p:txBody>
@@ -9059,7 +9088,7 @@
       </p:sp>
       <p:graphicFrame>
         <p:nvGraphicFramePr>
-          <p:cNvPr id="4" name="Answer table"/>
+          <p:cNvPr id="4" name="Answer table" descr="Frequency table of the ten sibling counts: 0 occurs twice, 1 four times, 2 twice, 3 once and 4 once, with relative frequencies 0.20, 0.40, 0.20, 0.10 and 0.10."/>
           <p:cNvGraphicFramePr>
             <a:graphicFrameLocks noGrp="1"/>
           </p:cNvGraphicFramePr>
@@ -9866,7 +9895,7 @@
       </p:sp>
       <p:graphicFrame>
         <p:nvGraphicFramePr>
-          <p:cNvPr id="4" name="Answer table"/>
+          <p:cNvPr id="4" name="Answer table" descr="Frequency table using whole-number bins: 1 to 2 contains 3 values, 2 to 3 contains 4, 3 to 4 contains 6 and 4 to 5 contains 2, out of 15."/>
           <p:cNvGraphicFramePr>
             <a:graphicFrameLocks noGrp="1"/>
           </p:cNvGraphicFramePr>
@@ -10205,7 +10234,7 @@
       </p:graphicFrame>
       <p:graphicFrame>
         <p:nvGraphicFramePr>
-          <p:cNvPr id="6" name="Second binning"/>
+          <p:cNvPr id="6" name="Second binning" descr="The same fifteen values in bins of width 0.5, giving counts of 2, 1, 0, 4, 3, 3 and 2 - the 2.0 to 2.5 bin is empty."/>
           <p:cNvGraphicFramePr>
             <a:graphicFrameLocks noGrp="1"/>
           </p:cNvGraphicFramePr>
@@ -10963,7 +10992,7 @@
       </p:pic>
       <p:pic>
         <p:nvPicPr>
-          <p:cNvPr id="14" name="Picture 13">
+          <p:cNvPr id="14" name="Picture 13" descr="Table of the Old Faithful data: for each of 272 eruptions the eruption time in minutes and the waiting time until the next eruption. The first rows read 3.600 and 79, 1.800 and 54, 3.333 and 74.">
             <a:extLst>
               <a:ext uri="{FF2B5EF4-FFF2-40B4-BE49-F238E27FC236}">
                 <a16:creationId xmlns:a16="http://schemas.microsoft.com/office/drawing/2014/main" id="{9B6079F2-E75F-5FC2-3656-4040AC7A68F1}"/>
@@ -11057,7 +11086,7 @@
       </p:sp>
       <p:pic>
         <p:nvPicPr>
-          <p:cNvPr id="4" name="Picture 3">
+          <p:cNvPr id="4" name="Picture 3" descr="Frequency table of Old Faithful waiting times in ten-minute bins: under 50 minutes 21, 50 to 60 56, 60 to 70 26, 70 to 80 77, 80 to 90 80, over 90 12, with relative and cumulative relative frequencies.">
             <a:extLst>
               <a:ext uri="{FF2B5EF4-FFF2-40B4-BE49-F238E27FC236}">
                 <a16:creationId xmlns:a16="http://schemas.microsoft.com/office/drawing/2014/main" id="{BC445D82-BC54-E443-F806-44E9E15C1C53}"/>
@@ -11357,7 +11386,7 @@
       </p:sp>
       <p:graphicFrame>
         <p:nvGraphicFramePr>
-          <p:cNvPr id="5" name="Content Placeholder 2">
+          <p:cNvPr id="5" name="Content Placeholder 2" descr="Flow diagram: graphical descriptions of data start from frequency tables, which branch to qualitative variables (bar graph, pie chart, Pareto chart) and quantitative variables (dot plot, stem chart, histogram); both branches lead to describing the key features of the distribution - modal category, shape, center and variability.">
             <a:extLst>
               <a:ext uri="{FF2B5EF4-FFF2-40B4-BE49-F238E27FC236}">
                 <a16:creationId xmlns:a16="http://schemas.microsoft.com/office/drawing/2014/main" id="{B7A7144C-3BB9-B0B9-1DF4-7E20D741B2C9}"/>
@@ -12380,9 +12409,38 @@
           <a:chExt cx="0" cy="0"/>
         </a:xfrm>
       </p:grpSpPr>
+      <p:sp>
+        <p:nvSpPr>
+          <p:cNvPr id="900" name="Title 1"/>
+          <p:cNvSpPr>
+            <a:spLocks noGrp="1"/>
+          </p:cNvSpPr>
+          <p:nvPr>
+            <p:ph type="title"/>
+          </p:nvPr>
+        </p:nvSpPr>
+        <p:spPr>
+          <a:xfrm>
+            <a:off x="-8000000" y="0"/>
+            <a:ext cx="6000000" cy="800000"/>
+          </a:xfrm>
+        </p:spPr>
+        <p:txBody>
+          <a:bodyPr>
+            <a:normAutofit/>
+          </a:bodyPr>
+          <a:lstStyle/>
+          <a:p>
+            <a:r>
+              <a:rPr lang="en-US" sz="1800" dirty="0"/>
+              <a:t>Bar graph and pie chart of the teen survey</a:t>
+            </a:r>
+          </a:p>
+        </p:txBody>
+      </p:sp>
       <p:pic>
         <p:nvPicPr>
-          <p:cNvPr id="5" name="Picture 4">
+          <p:cNvPr id="5" name="Picture 4" descr="Bar graph of the teen survey responses in decreasing order - Never, Rarely, Sometimes, Often - with relative frequency on the vertical axis.">
             <a:extLst>
               <a:ext uri="{FF2B5EF4-FFF2-40B4-BE49-F238E27FC236}">
                 <a16:creationId xmlns:a16="http://schemas.microsoft.com/office/drawing/2014/main" id="{7EC6A261-0EA6-9E96-37C0-CB6898B1BD89}"/>
@@ -12412,7 +12470,7 @@
       </p:pic>
       <p:pic>
         <p:nvPicPr>
-          <p:cNvPr id="7" name="Picture 6">
+          <p:cNvPr id="7" name="Picture 6" descr="Pie chart of the teen survey with every slice labelled in place: Never 0.39, Rarely 0.29, Sometimes 0.24, Often 0.08.">
             <a:extLst>
               <a:ext uri="{FF2B5EF4-FFF2-40B4-BE49-F238E27FC236}">
                 <a16:creationId xmlns:a16="http://schemas.microsoft.com/office/drawing/2014/main" id="{FAAAEAA6-C6FF-BCA1-1B38-7E475B4066C9}"/>
@@ -12638,9 +12696,38 @@
           <a:chExt cx="0" cy="0"/>
         </a:xfrm>
       </p:grpSpPr>
+      <p:sp>
+        <p:nvSpPr>
+          <p:cNvPr id="900" name="Title 1"/>
+          <p:cNvSpPr>
+            <a:spLocks noGrp="1"/>
+          </p:cNvSpPr>
+          <p:nvPr>
+            <p:ph type="title"/>
+          </p:nvPr>
+        </p:nvSpPr>
+        <p:spPr>
+          <a:xfrm>
+            <a:off x="-8000000" y="0"/>
+            <a:ext cx="6000000" cy="800000"/>
+          </a:xfrm>
+        </p:spPr>
+        <p:txBody>
+          <a:bodyPr>
+            <a:normAutofit/>
+          </a:bodyPr>
+          <a:lstStyle/>
+          <a:p>
+            <a:r>
+              <a:rPr lang="en-US" sz="1800" dirty="0"/>
+              <a:t>Dot plot of Old Faithful waiting times</a:t>
+            </a:r>
+          </a:p>
+        </p:txBody>
+      </p:sp>
       <p:pic>
         <p:nvPicPr>
-          <p:cNvPr id="4" name="Picture 3">
+          <p:cNvPr id="4" name="Picture 3" descr="Dot plot of Old Faithful waiting times, one dot per eruption. The dots form two clusters, one around 50 to 55 minutes and a larger one around 78 to 83 minutes, with a thin gap near 67 minutes.">
             <a:extLst>
               <a:ext uri="{FF2B5EF4-FFF2-40B4-BE49-F238E27FC236}">
                 <a16:creationId xmlns:a16="http://schemas.microsoft.com/office/drawing/2014/main" id="{93CDB88E-8525-C007-528D-F06C6B57452E}"/>
@@ -12735,7 +12822,7 @@
       </p:sp>
       <p:pic>
         <p:nvPicPr>
-          <p:cNvPr id="6" name="Picture 5">
+          <p:cNvPr id="6" name="Picture 5" descr="Table of the car data: observation number, miles per gallon, cylinders and model, from the Mazda RX4 at 21.0 mpg with 6 cylinders through to the Volvo 142E at 21.4 mpg with 4 cylinders, 32 cars in all.">
             <a:extLst>
               <a:ext uri="{FF2B5EF4-FFF2-40B4-BE49-F238E27FC236}">
                 <a16:creationId xmlns:a16="http://schemas.microsoft.com/office/drawing/2014/main" id="{60B6F122-13F2-0495-B148-F9F908F242F4}"/>
@@ -12765,7 +12852,7 @@
       </p:pic>
       <p:pic>
         <p:nvPicPr>
-          <p:cNvPr id="1026" name="Picture 2" descr="The engine | How a Car Works">
+          <p:cNvPr id="1026" name="Picture 2" descr="Cutaway illustration of a car engine, labelling the camshaft, pistons, valves, crankshaft and flywheel.">
             <a:extLst>
               <a:ext uri="{FF2B5EF4-FFF2-40B4-BE49-F238E27FC236}">
                 <a16:creationId xmlns:a16="http://schemas.microsoft.com/office/drawing/2014/main" id="{E678D63E-B7D3-7D74-1055-221F6D88A1C9}"/>
@@ -12840,9 +12927,38 @@
           <a:chExt cx="0" cy="0"/>
         </a:xfrm>
       </p:grpSpPr>
+      <p:sp>
+        <p:nvSpPr>
+          <p:cNvPr id="900" name="Title 1"/>
+          <p:cNvSpPr>
+            <a:spLocks noGrp="1"/>
+          </p:cNvSpPr>
+          <p:nvPr>
+            <p:ph type="title"/>
+          </p:nvPr>
+        </p:nvSpPr>
+        <p:spPr>
+          <a:xfrm>
+            <a:off x="-8000000" y="0"/>
+            <a:ext cx="6000000" cy="800000"/>
+          </a:xfrm>
+        </p:spPr>
+        <p:txBody>
+          <a:bodyPr>
+            <a:normAutofit/>
+          </a:bodyPr>
+          <a:lstStyle/>
+          <a:p>
+            <a:r>
+              <a:rPr lang="en-US" sz="1800" dirty="0"/>
+              <a:t>Dot plot of miles per gallon by cylinder count</a:t>
+            </a:r>
+          </a:p>
+        </p:txBody>
+      </p:sp>
       <p:pic>
         <p:nvPicPr>
-          <p:cNvPr id="4" name="Picture 3">
+          <p:cNvPr id="4" name="Picture 3" descr="Dot plot of miles per gallon for 32 car models. Cylinder count is shown by both shape and colour: 4-cylinder cars are blue circles and reach the highest mileage, up to about 34 mpg; 6-cylinder cars are orange triangles clustered near 18 to 21; 8-cylinder cars are green squares and sit lowest, from about 10 to 19 mpg.">
             <a:extLst>
               <a:ext uri="{FF2B5EF4-FFF2-40B4-BE49-F238E27FC236}">
                 <a16:creationId xmlns:a16="http://schemas.microsoft.com/office/drawing/2014/main" id="{15BCE4F3-B78E-72F0-EC01-6B2C24A47E6E}"/>
@@ -13264,7 +13380,7 @@
           </a:prstGeom>
           <a:ln w="38100">
             <a:solidFill>
-              <a:srgbClr val="FF0000"/>
+              <a:srgbClr val="C00000"/>
             </a:solidFill>
             <a:tailEnd type="triangle"/>
           </a:ln>
@@ -13343,7 +13459,7 @@
           </a:prstGeom>
           <a:ln w="38100">
             <a:solidFill>
-              <a:srgbClr val="FF0000"/>
+              <a:srgbClr val="C00000"/>
             </a:solidFill>
             <a:tailEnd type="triangle"/>
           </a:ln>
@@ -13430,7 +13546,7 @@
       </p:sp>
       <p:pic>
         <p:nvPicPr>
-          <p:cNvPr id="6" name="Picture 5">
+          <p:cNvPr id="6" name="Picture 5" descr="Table of the car data: observation number, miles per gallon, cylinders and model, from the Mazda RX4 at 21.0 mpg with 6 cylinders through to the Volvo 142E at 21.4 mpg with 4 cylinders, 32 cars in all.">
             <a:extLst>
               <a:ext uri="{FF2B5EF4-FFF2-40B4-BE49-F238E27FC236}">
                 <a16:creationId xmlns:a16="http://schemas.microsoft.com/office/drawing/2014/main" id="{60B6F122-13F2-0495-B148-F9F908F242F4}"/>
@@ -13460,7 +13576,7 @@
       </p:pic>
       <p:pic>
         <p:nvPicPr>
-          <p:cNvPr id="4" name="Picture 3">
+          <p:cNvPr id="4" name="Picture 3" descr="Dot plot of miles per gallon for 32 car models. Cylinder count is shown by both shape and colour: 4-cylinder cars are blue circles and reach the highest mileage, up to about 34 mpg; 6-cylinder cars are orange triangles clustered near 18 to 21; 8-cylinder cars are green squares and sit lowest, from about 10 to 19 mpg.">
             <a:extLst>
               <a:ext uri="{FF2B5EF4-FFF2-40B4-BE49-F238E27FC236}">
                 <a16:creationId xmlns:a16="http://schemas.microsoft.com/office/drawing/2014/main" id="{FB701B9A-D517-32D0-A350-4500F634B187}"/>
@@ -13490,7 +13606,7 @@
       </p:pic>
       <p:pic>
         <p:nvPicPr>
-          <p:cNvPr id="7" name="Picture 6">
+          <p:cNvPr id="7" name="Picture 6" descr="Stem and leaf plot of the mileage figures, with stems 10 through 33 for the whole-number part and leaves for the first decimal.">
             <a:extLst>
               <a:ext uri="{FF2B5EF4-FFF2-40B4-BE49-F238E27FC236}">
                 <a16:creationId xmlns:a16="http://schemas.microsoft.com/office/drawing/2014/main" id="{C4E7196C-9CAB-32E1-5755-5C8C7E55C899}"/>
@@ -13520,7 +13636,7 @@
       </p:pic>
       <p:pic>
         <p:nvPicPr>
-          <p:cNvPr id="8" name="Picture 7">
+          <p:cNvPr id="8" name="Picture 7" descr="The same stem and leaf plot with the stems combined in pairs, giving a more compact display with stems 10, 12, 14 and so on.">
             <a:extLst>
               <a:ext uri="{FF2B5EF4-FFF2-40B4-BE49-F238E27FC236}">
                 <a16:creationId xmlns:a16="http://schemas.microsoft.com/office/drawing/2014/main" id="{D6849ACD-33DD-B90C-2FCD-2F174EB768EE}"/>
@@ -14660,7 +14776,7 @@
           <a:noFill/>
           <a:ln w="38100">
             <a:solidFill>
-              <a:srgbClr val="FF0000"/>
+              <a:srgbClr val="C00000"/>
             </a:solidFill>
           </a:ln>
         </p:spPr>
@@ -15310,7 +15426,7 @@
       </p:sp>
       <p:pic>
         <p:nvPicPr>
-          <p:cNvPr id="6" name="Picture 5">
+          <p:cNvPr id="6" name="Picture 5" descr="Histogram of the twenty practice observations in five bins, each bar coloured to match the bin marked in the list of values above it. The bars rise to a peak of six in the middle bin and fall away on both sides.">
             <a:extLst>
               <a:ext uri="{FF2B5EF4-FFF2-40B4-BE49-F238E27FC236}">
                 <a16:creationId xmlns:a16="http://schemas.microsoft.com/office/drawing/2014/main" id="{AD8586AA-4204-7713-BBA1-0EA1B4445967}"/>
@@ -17014,7 +17130,7 @@
                 <a:r>
                   <a:rPr lang="en-US" dirty="0">
                     <a:solidFill>
-                      <a:srgbClr val="FF0000"/>
+                      <a:srgbClr val="C00000"/>
                     </a:solidFill>
                   </a:rPr>
                   <a:t>Square root method:       </a:t>
@@ -17024,7 +17140,7 @@
                     <m:r>
                       <a:rPr lang="en-US" b="0" i="1" smtClean="0">
                         <a:solidFill>
-                          <a:srgbClr val="FF0000"/>
+                          <a:srgbClr val="C00000"/>
                         </a:solidFill>
                         <a:latin typeface="Cambria Math" panose="02040503050406030204" pitchFamily="18" charset="0"/>
                       </a:rPr>
@@ -17033,7 +17149,7 @@
                     <m:r>
                       <a:rPr lang="en-US" b="0" i="0" smtClean="0">
                         <a:solidFill>
-                          <a:srgbClr val="FF0000"/>
+                          <a:srgbClr val="C00000"/>
                         </a:solidFill>
                         <a:latin typeface="Cambria Math" panose="02040503050406030204" pitchFamily="18" charset="0"/>
                       </a:rPr>
@@ -17045,7 +17161,7 @@
                       </m:rPr>
                       <a:rPr lang="en-US" b="0" i="0" smtClean="0">
                         <a:solidFill>
-                          <a:srgbClr val="FF0000"/>
+                          <a:srgbClr val="C00000"/>
                         </a:solidFill>
                         <a:latin typeface="Cambria Math" panose="02040503050406030204" pitchFamily="18" charset="0"/>
                       </a:rPr>
@@ -17054,7 +17170,7 @@
                     <m:r>
                       <a:rPr lang="en-US" b="0" i="0" smtClean="0">
                         <a:solidFill>
-                          <a:srgbClr val="FF0000"/>
+                          <a:srgbClr val="C00000"/>
                         </a:solidFill>
                         <a:latin typeface="Cambria Math" panose="02040503050406030204" pitchFamily="18" charset="0"/>
                       </a:rPr>
@@ -17066,7 +17182,7 @@
                         <m:ctrlPr>
                           <a:rPr lang="en-US" b="0" i="1" smtClean="0">
                             <a:solidFill>
-                              <a:srgbClr val="FF0000"/>
+                              <a:srgbClr val="C00000"/>
                             </a:solidFill>
                             <a:latin typeface="Cambria Math" panose="02040503050406030204" pitchFamily="18" charset="0"/>
                           </a:rPr>
@@ -17077,7 +17193,7 @@
                         <m:r>
                           <a:rPr lang="en-US" b="0" i="1" smtClean="0">
                             <a:solidFill>
-                              <a:srgbClr val="FF0000"/>
+                              <a:srgbClr val="C00000"/>
                             </a:solidFill>
                             <a:latin typeface="Cambria Math" panose="02040503050406030204" pitchFamily="18" charset="0"/>
                           </a:rPr>
@@ -17088,7 +17204,7 @@
                     <m:r>
                       <a:rPr lang="en-US" b="0" i="1" smtClean="0">
                         <a:solidFill>
-                          <a:srgbClr val="FF0000"/>
+                          <a:srgbClr val="C00000"/>
                         </a:solidFill>
                         <a:latin typeface="Cambria Math" panose="02040503050406030204" pitchFamily="18" charset="0"/>
                       </a:rPr>
@@ -17099,7 +17215,7 @@
                 <a:r>
                   <a:rPr lang="en-US" dirty="0">
                     <a:solidFill>
-                      <a:srgbClr val="FF0000"/>
+                      <a:srgbClr val="C00000"/>
                     </a:solidFill>
                   </a:rPr>
                   <a:t>       </a:t>
@@ -17110,7 +17226,7 @@
                 </a:r>
                 <a:endParaRPr lang="en-US" dirty="0">
                   <a:solidFill>
-                    <a:srgbClr val="FF0000"/>
+                    <a:srgbClr val="C00000"/>
                   </a:solidFill>
                 </a:endParaRPr>
               </a:p>
@@ -17384,7 +17500,7 @@
                   <a:buNone/>
                 </a:pPr>
                 <a:r>
-                  <a:rPr lang="en-US" sz="1050" b="0" i="0" dirty="0">
+                  <a:rPr lang="en-US" sz="1200" b="0" i="0" dirty="0">
                     <a:solidFill>
                       <a:srgbClr val="222222"/>
                     </a:solidFill>
@@ -17394,7 +17510,7 @@
                   <a:t>[1] Sturges, Herbert A. "The choice of a class interval." Journal of the </a:t>
                 </a:r>
                 <a:r>
-                  <a:rPr lang="en-US" sz="1050" b="0" i="0" dirty="0" err="1">
+                  <a:rPr lang="en-US" sz="1200" b="0" i="0" dirty="0" err="1">
                     <a:solidFill>
                       <a:srgbClr val="222222"/>
                     </a:solidFill>
@@ -17404,7 +17520,7 @@
                   <a:t>american</a:t>
                 </a:r>
                 <a:r>
-                  <a:rPr lang="en-US" sz="1050" b="0" i="0" dirty="0">
+                  <a:rPr lang="en-US" sz="1200" b="0" i="0" dirty="0">
                     <a:solidFill>
                       <a:srgbClr val="222222"/>
                     </a:solidFill>
@@ -17419,7 +17535,7 @@
                   <a:buNone/>
                 </a:pPr>
                 <a:r>
-                  <a:rPr lang="en-US" sz="1050" dirty="0">
+                  <a:rPr lang="en-US" sz="1200" dirty="0">
                     <a:solidFill>
                       <a:srgbClr val="222222"/>
                     </a:solidFill>
@@ -17428,7 +17544,7 @@
                   <a:t>[2] </a:t>
                 </a:r>
                 <a:r>
-                  <a:rPr lang="en-US" sz="1050" b="0" i="0" dirty="0">
+                  <a:rPr lang="en-US" sz="1200" b="0" i="0" dirty="0">
                     <a:solidFill>
                       <a:srgbClr val="222222"/>
                     </a:solidFill>
@@ -17438,7 +17554,7 @@
                   <a:t>Lane, David. </a:t>
                 </a:r>
                 <a:r>
-                  <a:rPr lang="en-US" sz="1050" b="0" i="1" dirty="0">
+                  <a:rPr lang="en-US" sz="1200" b="0" i="1" dirty="0">
                     <a:solidFill>
                       <a:srgbClr val="222222"/>
                     </a:solidFill>
@@ -17448,7 +17564,7 @@
                   <a:t>Online statistics education: A multimedia course of study</a:t>
                 </a:r>
                 <a:r>
-                  <a:rPr lang="en-US" sz="1050" b="0" i="0" dirty="0">
+                  <a:rPr lang="en-US" sz="1200" b="0" i="0" dirty="0">
                     <a:solidFill>
                       <a:srgbClr val="222222"/>
                     </a:solidFill>
@@ -17679,7 +17795,7 @@
       </p:sp>
       <p:pic>
         <p:nvPicPr>
-          <p:cNvPr id="5" name="Picture 4">
+          <p:cNvPr id="5" name="Picture 4" descr="Histogram of Old Faithful waiting times using only three very wide bins, too crude to show the two clusters.">
             <a:extLst>
               <a:ext uri="{FF2B5EF4-FFF2-40B4-BE49-F238E27FC236}">
                 <a16:creationId xmlns:a16="http://schemas.microsoft.com/office/drawing/2014/main" id="{1EB687C5-40BA-D0EA-5A63-59C5B8F474B5}"/>
@@ -17709,7 +17825,7 @@
       </p:pic>
       <p:pic>
         <p:nvPicPr>
-          <p:cNvPr id="9" name="Picture 8">
+          <p:cNvPr id="9" name="Picture 8" descr="The same waiting times in about a dozen bins, which shows the two clusters clearly.">
             <a:extLst>
               <a:ext uri="{FF2B5EF4-FFF2-40B4-BE49-F238E27FC236}">
                 <a16:creationId xmlns:a16="http://schemas.microsoft.com/office/drawing/2014/main" id="{958A48EC-CDD0-04BA-47F9-5B4CC4AE0872}"/>
@@ -17739,7 +17855,7 @@
       </p:pic>
       <p:pic>
         <p:nvPicPr>
-          <p:cNvPr id="11" name="Picture 10">
+          <p:cNvPr id="11" name="Picture 10" descr="The same waiting times in very many narrow bins, which breaks the shape into short bars and gaps.">
             <a:extLst>
               <a:ext uri="{FF2B5EF4-FFF2-40B4-BE49-F238E27FC236}">
                 <a16:creationId xmlns:a16="http://schemas.microsoft.com/office/drawing/2014/main" id="{78740C87-4A50-38E8-A519-55957D15C22E}"/>
@@ -17799,7 +17915,7 @@
       </p:grpSpPr>
       <p:pic>
         <p:nvPicPr>
-          <p:cNvPr id="4" name="Picture 3">
+          <p:cNvPr id="4" name="Picture 3" descr="Frequency table of Old Faithful waiting times in ten-minute bins with frequency, relative frequency and cumulative relative frequency.">
             <a:extLst>
               <a:ext uri="{FF2B5EF4-FFF2-40B4-BE49-F238E27FC236}">
                 <a16:creationId xmlns:a16="http://schemas.microsoft.com/office/drawing/2014/main" id="{43F76311-3A9D-2395-F921-58D84AC2F9B4}"/>
@@ -17829,7 +17945,7 @@
       </p:pic>
       <p:pic>
         <p:nvPicPr>
-          <p:cNvPr id="10" name="Picture 9">
+          <p:cNvPr id="10" name="Picture 9" descr="Histogram of Old Faithful waiting times in ten-minute bins, frequency on the vertical axis, showing two peaks either side of a dip near 65 minutes.">
             <a:extLst>
               <a:ext uri="{FF2B5EF4-FFF2-40B4-BE49-F238E27FC236}">
                 <a16:creationId xmlns:a16="http://schemas.microsoft.com/office/drawing/2014/main" id="{9AC59B7A-4888-2F53-4913-9DA0E60378A7}"/>
@@ -17859,7 +17975,7 @@
       </p:pic>
       <p:pic>
         <p:nvPicPr>
-          <p:cNvPr id="8" name="Picture 7">
+          <p:cNvPr id="8" name="Picture 7" descr="The same histogram with relative frequency on the vertical axis; the shape is identical, only the scale changes.">
             <a:extLst>
               <a:ext uri="{FF2B5EF4-FFF2-40B4-BE49-F238E27FC236}">
                 <a16:creationId xmlns:a16="http://schemas.microsoft.com/office/drawing/2014/main" id="{978CA529-7CC3-CAE2-9847-392C83BDC9D6}"/>
@@ -17960,9 +18076,38 @@
           <a:chExt cx="0" cy="0"/>
         </a:xfrm>
       </p:grpSpPr>
+      <p:sp>
+        <p:nvSpPr>
+          <p:cNvPr id="900" name="Title 1"/>
+          <p:cNvSpPr>
+            <a:spLocks noGrp="1"/>
+          </p:cNvSpPr>
+          <p:nvPr>
+            <p:ph type="title"/>
+          </p:nvPr>
+        </p:nvSpPr>
+        <p:spPr>
+          <a:xfrm>
+            <a:off x="-8000000" y="0"/>
+            <a:ext cx="6000000" cy="800000"/>
+          </a:xfrm>
+        </p:spPr>
+        <p:txBody>
+          <a:bodyPr>
+            <a:normAutofit/>
+          </a:bodyPr>
+          <a:lstStyle/>
+          <a:p>
+            <a:r>
+              <a:rPr lang="en-US" sz="1800" dirty="0"/>
+              <a:t>Where we stopped on Friday: the teen cell-phone survey</a:t>
+            </a:r>
+          </a:p>
+        </p:txBody>
+      </p:sp>
       <p:pic>
         <p:nvPicPr>
-          <p:cNvPr id="9" name="Picture 8">
+          <p:cNvPr id="9" name="Picture 8" descr="Bar chart of 743 U.S. teenagers answering whether checking their phone makes them lose focus in class. Never 0.39, Rarely 0.29, Sometimes 0.24, Often 0.08 - most teens say they rarely or never lose focus.">
             <a:extLst>
               <a:ext uri="{FF2B5EF4-FFF2-40B4-BE49-F238E27FC236}">
                 <a16:creationId xmlns:a16="http://schemas.microsoft.com/office/drawing/2014/main" id="{61327843-2234-FD4B-8B1B-E62A4EDD2B5A}"/>
@@ -18606,7 +18751,7 @@
       </p:sp>
       <p:pic>
         <p:nvPicPr>
-          <p:cNvPr id="4" name="Figure"/>
+          <p:cNvPr id="4" name="Figure" descr="Bar chart of the same teen survey with the tallest bar, Never at 289, picked out in red as the modal category. Rarely 216, Sometimes 178, Often 60."/>
           <p:cNvPicPr>
             <a:picLocks noChangeAspect="1"/>
           </p:cNvPicPr>
@@ -18827,7 +18972,7 @@
       </p:sp>
       <p:pic>
         <p:nvPicPr>
-          <p:cNvPr id="4" name="Figure"/>
+          <p:cNvPr id="4" name="Figure" descr="Four histograms showing different shapes: values piling up in the middle and thinning evenly on both sides; piling up on the left with a long trail to the right; piling up on the right with a long trail to the left; and piling up in two separate places with a gap between them."/>
           <p:cNvPicPr>
             <a:picLocks noChangeAspect="1"/>
           </p:cNvPicPr>
@@ -18849,42 +18994,6 @@
           </a:prstGeom>
         </p:spPr>
       </p:pic>
-      <p:sp>
-        <p:nvSpPr>
-          <p:cNvPr id="5" name="Takeaway"/>
-          <p:cNvSpPr txBox="1"/>
-          <p:nvPr/>
-        </p:nvSpPr>
-        <p:spPr>
-          <a:xfrm>
-            <a:off x="838200" y="6340000"/>
-            <a:ext cx="10515600" cy="900000"/>
-          </a:xfrm>
-          <a:prstGeom prst="rect">
-            <a:avLst/>
-          </a:prstGeom>
-          <a:noFill/>
-        </p:spPr>
-        <p:txBody>
-          <a:bodyPr wrap="square" lIns="0" tIns="0" rIns="0" bIns="0">
-            <a:normAutofit/>
-          </a:bodyPr>
-          <a:lstStyle/>
-          <a:p>
-            <a:pPr marL="0" indent="0">
-              <a:buNone/>
-            </a:pPr>
-            <a:r>
-              <a:rPr lang="en-US" sz="1600" b="1" dirty="0">
-                <a:solidFill>
-                  <a:srgbClr val="C00000"/>
-                </a:solidFill>
-              </a:rPr>
-              <a:t>For now just describe what you see: where do the values pile up, and how do they trail off on each side? The names for these shapes come later.</a:t>
-            </a:r>
-          </a:p>
-        </p:txBody>
-      </p:sp>
     </p:spTree>
     <p:extLst>
       <p:ext uri="{BB962C8B-B14F-4D97-AF65-F5344CB8AC3E}">
@@ -18895,81 +19004,6 @@
   <p:clrMapOvr>
     <a:masterClrMapping/>
   </p:clrMapOvr>
-  <p:timing>
-    <p:tnLst>
-      <p:par>
-        <p:cTn id="1" dur="indefinite" restart="never" nodeType="tmRoot">
-          <p:childTnLst>
-            <p:seq concurrent="1" nextAc="seek">
-              <p:cTn id="2" dur="indefinite" nodeType="mainSeq">
-                <p:childTnLst>
-                  <p:par>
-                    <p:cTn id="3" fill="hold">
-                      <p:stCondLst>
-                        <p:cond delay="indefinite"/>
-                      </p:stCondLst>
-                      <p:childTnLst>
-                        <p:par>
-                          <p:cTn id="4" fill="hold">
-                            <p:stCondLst>
-                              <p:cond delay="0"/>
-                            </p:stCondLst>
-                            <p:childTnLst>
-                              <p:par>
-                                <p:cTn id="5" presetID="1" presetClass="entr" presetSubtype="0" fill="hold" nodeType="clickEffect">
-                                  <p:stCondLst>
-                                    <p:cond delay="0"/>
-                                  </p:stCondLst>
-                                  <p:childTnLst>
-                                    <p:set>
-                                      <p:cBhvr>
-                                        <p:cTn id="6" dur="1" fill="hold">
-                                          <p:stCondLst>
-                                            <p:cond delay="0"/>
-                                          </p:stCondLst>
-                                        </p:cTn>
-                                        <p:tgtEl>
-                                          <p:spTgt spid="5"/>
-                                        </p:tgtEl>
-                                        <p:attrNameLst>
-                                          <p:attrName>style.visibility</p:attrName>
-                                        </p:attrNameLst>
-                                      </p:cBhvr>
-                                      <p:to>
-                                        <p:strVal val="visible"/>
-                                      </p:to>
-                                    </p:set>
-                                  </p:childTnLst>
-                                </p:cTn>
-                              </p:par>
-                            </p:childTnLst>
-                          </p:cTn>
-                        </p:par>
-                      </p:childTnLst>
-                    </p:cTn>
-                  </p:par>
-                </p:childTnLst>
-              </p:cTn>
-              <p:prevCondLst>
-                <p:cond evt="onPrev" delay="0">
-                  <p:tgtEl>
-                    <p:sldTgt/>
-                  </p:tgtEl>
-                </p:cond>
-              </p:prevCondLst>
-              <p:nextCondLst>
-                <p:cond evt="onNext" delay="0">
-                  <p:tgtEl>
-                    <p:sldTgt/>
-                  </p:tgtEl>
-                </p:cond>
-              </p:nextCondLst>
-            </p:seq>
-          </p:childTnLst>
-        </p:cTn>
-      </p:par>
-    </p:tnLst>
-  </p:timing>
 </p:sld>
 </file>
 
@@ -19048,7 +19082,7 @@
       </p:sp>
       <p:pic>
         <p:nvPicPr>
-          <p:cNvPr id="4" name="Figure"/>
+          <p:cNvPr id="4" name="Figure" descr="Two histograms with the mean drawn as a solid red line and the tallest bar marked by a dashed grey line. On the evenly piled distribution the mean sits under the peak; where the values trail off to the right the mean is pulled away from the peak, toward the tail."/>
           <p:cNvPicPr>
             <a:picLocks noChangeAspect="1"/>
           </p:cNvPicPr>
@@ -19101,7 +19135,7 @@
                   <a:srgbClr val="C00000"/>
                 </a:solidFill>
               </a:rPr>
-              <a:t>When the values pile up evenly the mean sits under the peak. When they trail off to one side the tail drags the mean away from where most of the data actually are – so the mean alone can mislead. Week 3 adds a second measure of center: the median.</a:t>
+              <a:t>When the values pile up evenly the mean sits under the peak. When they trail off to one side the tail drags the mean away from where most of the data actually are. the mean alone can mislead. </a:t>
             </a:r>
           </a:p>
         </p:txBody>
@@ -19269,7 +19303,7 @@
       </p:sp>
       <p:pic>
         <p:nvPicPr>
-          <p:cNvPr id="4" name="Figure"/>
+          <p:cNvPr id="4" name="Figure" descr="Two histograms on identical axes with the same center near 50. The first is narrow, with values packed close to the center; the second is far wider, spreading from about 10 to 90."/>
           <p:cNvPicPr>
             <a:picLocks noChangeAspect="1"/>
           </p:cNvPicPr>
@@ -19322,21 +19356,24 @@
                   <a:srgbClr val="C00000"/>
                 </a:solidFill>
               </a:rPr>
-              <a:t>Both distributions have the same center, and the axes are identical. Everything that differs between these two pictures is variability: how much the </a:t>
-            </a:r>
-            <a:r>
-              <a:rPr lang="en-US" sz="1600" b="1">
+              <a:t>Both distributions have the same center, and the axes are identical. Everything that differs between these two pictures is variability: </a:t>
+            </a:r>
+            <a:r>
+              <a:rPr lang="en-US" sz="1600" b="1" dirty="0" err="1">
                 <a:solidFill>
                   <a:srgbClr val="C00000"/>
                 </a:solidFill>
               </a:rPr>
-              <a:t>data spread out.</a:t>
-            </a:r>
-            <a:endParaRPr lang="en-US" sz="1600" b="1" dirty="0">
-              <a:solidFill>
-                <a:srgbClr val="C00000"/>
-              </a:solidFill>
-            </a:endParaRPr>
+              <a:t>e.g</a:t>
+            </a:r>
+            <a:r>
+              <a:rPr lang="en-US" sz="1600" b="1" dirty="0">
+                <a:solidFill>
+                  <a:srgbClr val="C00000"/>
+                </a:solidFill>
+              </a:rPr>
+              <a:t> how much the data spread out.</a:t>
+            </a:r>
           </a:p>
         </p:txBody>
       </p:sp>

</xml_diff>